<commit_message>
added the slide for PID
</commit_message>
<xml_diff>
--- a/presentation/Governor Presentation.pptx
+++ b/presentation/Governor Presentation.pptx
@@ -1,26 +1,219 @@
 
 <file path=ppt/presentation.xml><?xml version="1.0" encoding="utf-8"?>
-<p:presentation xmlns:a="http://schemas.openxmlformats.org/drawingml/2006/main" xmlns:p="http://schemas.openxmlformats.org/presentationml/2006/main" xmlns:r="http://schemas.openxmlformats.org/officeDocument/2006/relationships" xmlns:p14="http://schemas.microsoft.com/office/powerpoint/2010/main" xmlns:p15="http://schemas.microsoft.com/office/powerpoint/2012/main" xmlns:mc="http://schemas.openxmlformats.org/markup-compatibility/2006">
+<p:presentation xmlns:a="http://schemas.openxmlformats.org/drawingml/2006/main" xmlns:r="http://schemas.openxmlformats.org/officeDocument/2006/relationships" xmlns:p="http://schemas.openxmlformats.org/presentationml/2006/main">
   <p:sldMasterIdLst>
-    <p:sldMasterId id="2147483648" r:id="rId2"/>
+    <p:sldMasterId id="2147483648" r:id="rId1"/>
   </p:sldMasterIdLst>
   <p:sldIdLst>
-    <p:sldId id="256" r:id="rId3"/>
-    <p:sldId id="257" r:id="rId4"/>
-    <p:sldId id="258" r:id="rId5"/>
-    <p:sldId id="259" r:id="rId6"/>
-    <p:sldId id="260" r:id="rId7"/>
-    <p:sldId id="261" r:id="rId8"/>
-    <p:sldId id="262" r:id="rId9"/>
-    <p:sldId id="263" r:id="rId10"/>
+    <p:sldId id="256" r:id="rId2"/>
+    <p:sldId id="257" r:id="rId3"/>
+    <p:sldId id="258" r:id="rId4"/>
+    <p:sldId id="259" r:id="rId5"/>
+    <p:sldId id="260" r:id="rId6"/>
+    <p:sldId id="261" r:id="rId7"/>
+    <p:sldId id="262" r:id="rId8"/>
+    <p:sldId id="263" r:id="rId9"/>
   </p:sldIdLst>
   <p:sldSz cx="10080625" cy="5670550"/>
   <p:notesSz cx="7559675" cy="10691813"/>
+  <p:defaultTextStyle>
+    <a:defPPr>
+      <a:defRPr lang="en-SI"/>
+    </a:defPPr>
+    <a:lvl1pPr marL="0" algn="l" defTabSz="914400" rtl="0" eaLnBrk="1" latinLnBrk="0" hangingPunct="1">
+      <a:defRPr sz="1800" kern="1200">
+        <a:solidFill>
+          <a:schemeClr val="tx1"/>
+        </a:solidFill>
+        <a:latin typeface="+mn-lt"/>
+        <a:ea typeface="+mn-ea"/>
+        <a:cs typeface="+mn-cs"/>
+      </a:defRPr>
+    </a:lvl1pPr>
+    <a:lvl2pPr marL="457200" algn="l" defTabSz="914400" rtl="0" eaLnBrk="1" latinLnBrk="0" hangingPunct="1">
+      <a:defRPr sz="1800" kern="1200">
+        <a:solidFill>
+          <a:schemeClr val="tx1"/>
+        </a:solidFill>
+        <a:latin typeface="+mn-lt"/>
+        <a:ea typeface="+mn-ea"/>
+        <a:cs typeface="+mn-cs"/>
+      </a:defRPr>
+    </a:lvl2pPr>
+    <a:lvl3pPr marL="914400" algn="l" defTabSz="914400" rtl="0" eaLnBrk="1" latinLnBrk="0" hangingPunct="1">
+      <a:defRPr sz="1800" kern="1200">
+        <a:solidFill>
+          <a:schemeClr val="tx1"/>
+        </a:solidFill>
+        <a:latin typeface="+mn-lt"/>
+        <a:ea typeface="+mn-ea"/>
+        <a:cs typeface="+mn-cs"/>
+      </a:defRPr>
+    </a:lvl3pPr>
+    <a:lvl4pPr marL="1371600" algn="l" defTabSz="914400" rtl="0" eaLnBrk="1" latinLnBrk="0" hangingPunct="1">
+      <a:defRPr sz="1800" kern="1200">
+        <a:solidFill>
+          <a:schemeClr val="tx1"/>
+        </a:solidFill>
+        <a:latin typeface="+mn-lt"/>
+        <a:ea typeface="+mn-ea"/>
+        <a:cs typeface="+mn-cs"/>
+      </a:defRPr>
+    </a:lvl4pPr>
+    <a:lvl5pPr marL="1828800" algn="l" defTabSz="914400" rtl="0" eaLnBrk="1" latinLnBrk="0" hangingPunct="1">
+      <a:defRPr sz="1800" kern="1200">
+        <a:solidFill>
+          <a:schemeClr val="tx1"/>
+        </a:solidFill>
+        <a:latin typeface="+mn-lt"/>
+        <a:ea typeface="+mn-ea"/>
+        <a:cs typeface="+mn-cs"/>
+      </a:defRPr>
+    </a:lvl5pPr>
+    <a:lvl6pPr marL="2286000" algn="l" defTabSz="914400" rtl="0" eaLnBrk="1" latinLnBrk="0" hangingPunct="1">
+      <a:defRPr sz="1800" kern="1200">
+        <a:solidFill>
+          <a:schemeClr val="tx1"/>
+        </a:solidFill>
+        <a:latin typeface="+mn-lt"/>
+        <a:ea typeface="+mn-ea"/>
+        <a:cs typeface="+mn-cs"/>
+      </a:defRPr>
+    </a:lvl6pPr>
+    <a:lvl7pPr marL="2743200" algn="l" defTabSz="914400" rtl="0" eaLnBrk="1" latinLnBrk="0" hangingPunct="1">
+      <a:defRPr sz="1800" kern="1200">
+        <a:solidFill>
+          <a:schemeClr val="tx1"/>
+        </a:solidFill>
+        <a:latin typeface="+mn-lt"/>
+        <a:ea typeface="+mn-ea"/>
+        <a:cs typeface="+mn-cs"/>
+      </a:defRPr>
+    </a:lvl7pPr>
+    <a:lvl8pPr marL="3200400" algn="l" defTabSz="914400" rtl="0" eaLnBrk="1" latinLnBrk="0" hangingPunct="1">
+      <a:defRPr sz="1800" kern="1200">
+        <a:solidFill>
+          <a:schemeClr val="tx1"/>
+        </a:solidFill>
+        <a:latin typeface="+mn-lt"/>
+        <a:ea typeface="+mn-ea"/>
+        <a:cs typeface="+mn-cs"/>
+      </a:defRPr>
+    </a:lvl8pPr>
+    <a:lvl9pPr marL="3657600" algn="l" defTabSz="914400" rtl="0" eaLnBrk="1" latinLnBrk="0" hangingPunct="1">
+      <a:defRPr sz="1800" kern="1200">
+        <a:solidFill>
+          <a:schemeClr val="tx1"/>
+        </a:solidFill>
+        <a:latin typeface="+mn-lt"/>
+        <a:ea typeface="+mn-ea"/>
+        <a:cs typeface="+mn-cs"/>
+      </a:defRPr>
+    </a:lvl9pPr>
+  </p:defaultTextStyle>
 </p:presentation>
 </file>
 
+<file path=ppt/changesInfos/changesInfo1.xml><?xml version="1.0" encoding="utf-8"?>
+<pc:chgInfo xmlns:a="http://schemas.openxmlformats.org/drawingml/2006/main" xmlns:r="http://schemas.openxmlformats.org/officeDocument/2006/relationships" xmlns:ac="http://schemas.microsoft.com/office/drawing/2013/main/command" xmlns:pc="http://schemas.microsoft.com/office/powerpoint/2013/main/command">
+  <pc:docChgLst>
+    <pc:chgData name="Adam Rakun" userId="8052db6c05b989cf" providerId="LiveId" clId="{0BF334EB-8488-46D5-99AB-7FABFFE2AE92}"/>
+    <pc:docChg chg="undo custSel modSld">
+      <pc:chgData name="Adam Rakun" userId="8052db6c05b989cf" providerId="LiveId" clId="{0BF334EB-8488-46D5-99AB-7FABFFE2AE92}" dt="2026-01-28T15:40:17.163" v="144" actId="20577"/>
+      <pc:docMkLst>
+        <pc:docMk/>
+      </pc:docMkLst>
+      <pc:sldChg chg="modSp mod">
+        <pc:chgData name="Adam Rakun" userId="8052db6c05b989cf" providerId="LiveId" clId="{0BF334EB-8488-46D5-99AB-7FABFFE2AE92}" dt="2026-01-28T15:19:13.068" v="15" actId="27636"/>
+        <pc:sldMkLst>
+          <pc:docMk/>
+          <pc:sldMk cId="0" sldId="257"/>
+        </pc:sldMkLst>
+        <pc:spChg chg="mod">
+          <ac:chgData name="Adam Rakun" userId="8052db6c05b989cf" providerId="LiveId" clId="{0BF334EB-8488-46D5-99AB-7FABFFE2AE92}" dt="2026-01-28T15:19:13.068" v="15" actId="27636"/>
+          <ac:spMkLst>
+            <pc:docMk/>
+            <pc:sldMk cId="0" sldId="257"/>
+            <ac:spMk id="14" creationId="{00000000-0000-0000-0000-000000000000}"/>
+          </ac:spMkLst>
+        </pc:spChg>
+      </pc:sldChg>
+      <pc:sldChg chg="modSp mod">
+        <pc:chgData name="Adam Rakun" userId="8052db6c05b989cf" providerId="LiveId" clId="{0BF334EB-8488-46D5-99AB-7FABFFE2AE92}" dt="2026-01-28T15:19:13.073" v="16" actId="27636"/>
+        <pc:sldMkLst>
+          <pc:docMk/>
+          <pc:sldMk cId="0" sldId="260"/>
+        </pc:sldMkLst>
+        <pc:spChg chg="mod">
+          <ac:chgData name="Adam Rakun" userId="8052db6c05b989cf" providerId="LiveId" clId="{0BF334EB-8488-46D5-99AB-7FABFFE2AE92}" dt="2026-01-28T15:19:13.073" v="16" actId="27636"/>
+          <ac:spMkLst>
+            <pc:docMk/>
+            <pc:sldMk cId="0" sldId="260"/>
+            <ac:spMk id="20" creationId="{00000000-0000-0000-0000-000000000000}"/>
+          </ac:spMkLst>
+        </pc:spChg>
+      </pc:sldChg>
+      <pc:sldChg chg="addSp delSp modSp mod">
+        <pc:chgData name="Adam Rakun" userId="8052db6c05b989cf" providerId="LiveId" clId="{0BF334EB-8488-46D5-99AB-7FABFFE2AE92}" dt="2026-01-28T15:40:17.163" v="144" actId="20577"/>
+        <pc:sldMkLst>
+          <pc:docMk/>
+          <pc:sldMk cId="0" sldId="262"/>
+        </pc:sldMkLst>
+        <pc:spChg chg="add mod">
+          <ac:chgData name="Adam Rakun" userId="8052db6c05b989cf" providerId="LiveId" clId="{0BF334EB-8488-46D5-99AB-7FABFFE2AE92}" dt="2026-01-28T15:19:13.049" v="14"/>
+          <ac:spMkLst>
+            <pc:docMk/>
+            <pc:sldMk cId="0" sldId="262"/>
+            <ac:spMk id="2" creationId="{75FBA287-C940-2E99-C48F-9F3E9B469729}"/>
+          </ac:spMkLst>
+        </pc:spChg>
+        <pc:spChg chg="add mod">
+          <ac:chgData name="Adam Rakun" userId="8052db6c05b989cf" providerId="LiveId" clId="{0BF334EB-8488-46D5-99AB-7FABFFE2AE92}" dt="2026-01-28T15:40:17.163" v="144" actId="20577"/>
+          <ac:spMkLst>
+            <pc:docMk/>
+            <pc:sldMk cId="0" sldId="262"/>
+            <ac:spMk id="3" creationId="{1B36280C-CA59-9431-AE44-ADEEA4A18FCA}"/>
+          </ac:spMkLst>
+        </pc:spChg>
+        <pc:spChg chg="mod">
+          <ac:chgData name="Adam Rakun" userId="8052db6c05b989cf" providerId="LiveId" clId="{0BF334EB-8488-46D5-99AB-7FABFFE2AE92}" dt="2026-01-28T15:19:49.068" v="24" actId="1076"/>
+          <ac:spMkLst>
+            <pc:docMk/>
+            <pc:sldMk cId="0" sldId="262"/>
+            <ac:spMk id="24" creationId="{00000000-0000-0000-0000-000000000000}"/>
+          </ac:spMkLst>
+        </pc:spChg>
+        <pc:spChg chg="add del">
+          <ac:chgData name="Adam Rakun" userId="8052db6c05b989cf" providerId="LiveId" clId="{0BF334EB-8488-46D5-99AB-7FABFFE2AE92}" dt="2026-01-28T15:19:15.165" v="17"/>
+          <ac:spMkLst>
+            <pc:docMk/>
+            <pc:sldMk cId="0" sldId="262"/>
+            <ac:spMk id="25" creationId="{00000000-0000-0000-0000-000000000000}"/>
+          </ac:spMkLst>
+        </pc:spChg>
+      </pc:sldChg>
+      <pc:sldChg chg="modSp mod">
+        <pc:chgData name="Adam Rakun" userId="8052db6c05b989cf" providerId="LiveId" clId="{0BF334EB-8488-46D5-99AB-7FABFFE2AE92}" dt="2026-01-28T15:16:09.004" v="3" actId="27636"/>
+        <pc:sldMkLst>
+          <pc:docMk/>
+          <pc:sldMk cId="0" sldId="263"/>
+        </pc:sldMkLst>
+        <pc:spChg chg="mod">
+          <ac:chgData name="Adam Rakun" userId="8052db6c05b989cf" providerId="LiveId" clId="{0BF334EB-8488-46D5-99AB-7FABFFE2AE92}" dt="2026-01-28T15:16:09.004" v="3" actId="27636"/>
+          <ac:spMkLst>
+            <pc:docMk/>
+            <pc:sldMk cId="0" sldId="263"/>
+            <ac:spMk id="27" creationId="{00000000-0000-0000-0000-000000000000}"/>
+          </ac:spMkLst>
+        </pc:spChg>
+      </pc:sldChg>
+    </pc:docChg>
+  </pc:docChgLst>
+</pc:chgInfo>
+</file>
+
 <file path=ppt/slideLayouts/slideLayout1.xml><?xml version="1.0" encoding="utf-8"?>
-<p:sldLayout xmlns:a="http://schemas.openxmlformats.org/drawingml/2006/main" xmlns:p="http://schemas.openxmlformats.org/presentationml/2006/main" xmlns:r="http://schemas.openxmlformats.org/officeDocument/2006/relationships" xmlns:p14="http://schemas.microsoft.com/office/powerpoint/2010/main" xmlns:p15="http://schemas.microsoft.com/office/powerpoint/2012/main" xmlns:mc="http://schemas.openxmlformats.org/markup-compatibility/2006" type="tx" preserve="1">
+<p:sldLayout xmlns:a="http://schemas.openxmlformats.org/drawingml/2006/main" xmlns:r="http://schemas.openxmlformats.org/officeDocument/2006/relationships" xmlns:p="http://schemas.openxmlformats.org/presentationml/2006/main" type="tx" preserve="1">
   <p:cSld name="Default">
     <p:spTree>
       <p:nvGrpSpPr>
@@ -60,14 +253,15 @@
           </a:ln>
         </p:spPr>
         <p:txBody>
-          <a:bodyPr lIns="0" rIns="0" tIns="0" bIns="0" anchor="ctr">
+          <a:bodyPr lIns="0" tIns="0" rIns="0" bIns="0" anchor="ctr">
             <a:noAutofit/>
           </a:bodyPr>
+          <a:lstStyle/>
           <a:p>
             <a:pPr indent="0" algn="ctr">
               <a:buNone/>
             </a:pPr>
-            <a:endParaRPr b="0" lang="en-US" sz="4400" spc="-1" strike="noStrike">
+            <a:endParaRPr lang="en-US" sz="4400" b="0" strike="noStrike" spc="-1">
               <a:solidFill>
                 <a:srgbClr val="000000"/>
               </a:solidFill>
@@ -100,9 +294,10 @@
           </a:ln>
         </p:spPr>
         <p:txBody>
-          <a:bodyPr lIns="0" rIns="0" tIns="0" bIns="0" anchor="t">
+          <a:bodyPr lIns="0" tIns="0" rIns="0" bIns="0" anchor="t">
             <a:normAutofit/>
           </a:bodyPr>
+          <a:lstStyle/>
           <a:p>
             <a:pPr indent="0">
               <a:spcBef>
@@ -110,7 +305,7 @@
               </a:spcBef>
               <a:buNone/>
             </a:pPr>
-            <a:endParaRPr b="0" lang="en-US" sz="3200" spc="-1" strike="noStrike">
+            <a:endParaRPr lang="en-US" sz="3200" b="0" strike="noStrike" spc="-1">
               <a:solidFill>
                 <a:srgbClr val="000000"/>
               </a:solidFill>
@@ -132,6 +327,7 @@
         <p:spPr/>
         <p:txBody>
           <a:bodyPr/>
+          <a:lstStyle/>
           <a:p>
             <a:r>
               <a:t>Footer</a:t>
@@ -141,7 +337,7 @@
       </p:sp>
       <p:sp>
         <p:nvSpPr>
-          <p:cNvPr id="5" name="PlaceHolder 4"/>
+          <p:cNvPr id="2" name="PlaceHolder 4"/>
           <p:cNvSpPr>
             <a:spLocks noGrp="1"/>
           </p:cNvSpPr>
@@ -152,16 +348,18 @@
         <p:spPr/>
         <p:txBody>
           <a:bodyPr/>
+          <a:lstStyle/>
           <a:p>
             <a:fld id="{171677AE-8188-4B05-A3FB-CCD03111BDDD}" type="slidenum">
-              <a:t>&lt;#&gt;</a:t>
+              <a:t>‹#›</a:t>
             </a:fld>
+            <a:endParaRPr/>
           </a:p>
         </p:txBody>
       </p:sp>
       <p:sp>
         <p:nvSpPr>
-          <p:cNvPr id="6" name="PlaceHolder 5"/>
+          <p:cNvPr id="3" name="PlaceHolder 5"/>
           <p:cNvSpPr>
             <a:spLocks noGrp="1"/>
           </p:cNvSpPr>
@@ -172,21 +370,22 @@
         <p:spPr/>
         <p:txBody>
           <a:bodyPr/>
-          <a:p>
-            <a:r>
-              <a:rPr lang="en-US"/>
-              <a:t/>
-            </a:r>
+          <a:lstStyle/>
+          <a:p>
+            <a:endParaRPr/>
           </a:p>
         </p:txBody>
       </p:sp>
     </p:spTree>
   </p:cSld>
+  <p:clrMapOvr>
+    <a:masterClrMapping/>
+  </p:clrMapOvr>
 </p:sldLayout>
 </file>
 
 <file path=ppt/slideLayouts/slideLayout2.xml><?xml version="1.0" encoding="utf-8"?>
-<p:sldLayout xmlns:a="http://schemas.openxmlformats.org/drawingml/2006/main" xmlns:p="http://schemas.openxmlformats.org/presentationml/2006/main" xmlns:r="http://schemas.openxmlformats.org/officeDocument/2006/relationships" xmlns:p14="http://schemas.microsoft.com/office/powerpoint/2010/main" xmlns:p15="http://schemas.microsoft.com/office/powerpoint/2012/main" xmlns:mc="http://schemas.openxmlformats.org/markup-compatibility/2006" type="title" preserve="1">
+<p:sldLayout xmlns:a="http://schemas.openxmlformats.org/drawingml/2006/main" xmlns:r="http://schemas.openxmlformats.org/officeDocument/2006/relationships" xmlns:p="http://schemas.openxmlformats.org/presentationml/2006/main" type="title" preserve="1">
   <p:cSld name="Default">
     <p:spTree>
       <p:nvGrpSpPr>
@@ -226,14 +425,15 @@
           </a:ln>
         </p:spPr>
         <p:txBody>
-          <a:bodyPr lIns="0" rIns="0" tIns="0" bIns="0" anchor="ctr">
+          <a:bodyPr lIns="0" tIns="0" rIns="0" bIns="0" anchor="ctr">
             <a:noAutofit/>
           </a:bodyPr>
+          <a:lstStyle/>
           <a:p>
             <a:pPr indent="0" algn="ctr">
               <a:buNone/>
             </a:pPr>
-            <a:endParaRPr b="0" lang="en-US" sz="4400" spc="-1" strike="noStrike">
+            <a:endParaRPr lang="en-US" sz="4400" b="0" strike="noStrike" spc="-1">
               <a:solidFill>
                 <a:srgbClr val="000000"/>
               </a:solidFill>
@@ -266,14 +466,15 @@
           </a:ln>
         </p:spPr>
         <p:txBody>
-          <a:bodyPr lIns="0" rIns="0" tIns="0" bIns="0" anchor="ctr">
+          <a:bodyPr lIns="0" tIns="0" rIns="0" bIns="0" anchor="ctr">
             <a:noAutofit/>
           </a:bodyPr>
+          <a:lstStyle/>
           <a:p>
             <a:pPr indent="0" algn="ctr">
               <a:buNone/>
             </a:pPr>
-            <a:endParaRPr b="0" lang="en-US" sz="3200" spc="-1" strike="noStrike">
+            <a:endParaRPr lang="en-US" sz="3200" b="0" strike="noStrike" spc="-1">
               <a:solidFill>
                 <a:srgbClr val="000000"/>
               </a:solidFill>
@@ -295,6 +496,7 @@
         <p:spPr/>
         <p:txBody>
           <a:bodyPr/>
+          <a:lstStyle/>
           <a:p>
             <a:r>
               <a:t>Footer</a:t>
@@ -315,10 +517,12 @@
         <p:spPr/>
         <p:txBody>
           <a:bodyPr/>
+          <a:lstStyle/>
           <a:p>
             <a:fld id="{00BF11CD-01C3-4470-9E57-0FB81789F2D9}" type="slidenum">
-              <a:t>&lt;#&gt;</a:t>
+              <a:t>‹#›</a:t>
             </a:fld>
+            <a:endParaRPr/>
           </a:p>
         </p:txBody>
       </p:sp>
@@ -335,22 +539,28 @@
         <p:spPr/>
         <p:txBody>
           <a:bodyPr/>
-          <a:p>
-            <a:r>
-              <a:rPr lang="en-US"/>
-              <a:t/>
-            </a:r>
+          <a:lstStyle/>
+          <a:p>
+            <a:endParaRPr/>
           </a:p>
         </p:txBody>
       </p:sp>
     </p:spTree>
   </p:cSld>
+  <p:clrMapOvr>
+    <a:masterClrMapping/>
+  </p:clrMapOvr>
 </p:sldLayout>
 </file>
 
 <file path=ppt/slideMasters/slideMaster1.xml><?xml version="1.0" encoding="utf-8"?>
-<p:sldMaster xmlns:a="http://schemas.openxmlformats.org/drawingml/2006/main" xmlns:p="http://schemas.openxmlformats.org/presentationml/2006/main" xmlns:r="http://schemas.openxmlformats.org/officeDocument/2006/relationships" xmlns:p14="http://schemas.microsoft.com/office/powerpoint/2010/main" xmlns:p15="http://schemas.microsoft.com/office/powerpoint/2012/main" xmlns:mc="http://schemas.openxmlformats.org/markup-compatibility/2006">
+<p:sldMaster xmlns:a="http://schemas.openxmlformats.org/drawingml/2006/main" xmlns:r="http://schemas.openxmlformats.org/officeDocument/2006/relationships" xmlns:p="http://schemas.openxmlformats.org/presentationml/2006/main">
   <p:cSld>
+    <p:bg>
+      <p:bgRef idx="1001">
+        <a:schemeClr val="bg1"/>
+      </p:bgRef>
+    </p:bg>
     <p:spTree>
       <p:nvGrpSpPr>
         <p:cNvPr id="1" name=""/>
@@ -367,7 +577,7 @@
       </p:grpSpPr>
       <p:sp>
         <p:nvSpPr>
-          <p:cNvPr id="0" name="PlaceHolder 1"/>
+          <p:cNvPr id="5" name="PlaceHolder 1"/>
           <p:cNvSpPr>
             <a:spLocks noGrp="1"/>
           </p:cNvSpPr>
@@ -389,15 +599,16 @@
           </a:ln>
         </p:spPr>
         <p:txBody>
-          <a:bodyPr lIns="0" rIns="0" tIns="0" bIns="0" anchor="ctr">
+          <a:bodyPr lIns="0" tIns="0" rIns="0" bIns="0" anchor="ctr">
             <a:noAutofit/>
           </a:bodyPr>
+          <a:lstStyle/>
           <a:p>
             <a:pPr indent="0" algn="ctr">
               <a:buNone/>
             </a:pPr>
             <a:r>
-              <a:rPr b="0" lang="en-US" sz="4400" spc="-1" strike="noStrike">
+              <a:rPr lang="en-US" sz="4400" b="0" strike="noStrike" spc="-1">
                 <a:solidFill>
                   <a:srgbClr val="000000"/>
                 </a:solidFill>
@@ -405,18 +616,12 @@
               </a:rPr>
               <a:t>Click to edit the title text format</a:t>
             </a:r>
-            <a:endParaRPr b="0" lang="en-US" sz="4400" spc="-1" strike="noStrike">
-              <a:solidFill>
-                <a:srgbClr val="000000"/>
-              </a:solidFill>
-              <a:latin typeface="Arial"/>
-            </a:endParaRPr>
           </a:p>
         </p:txBody>
       </p:sp>
       <p:sp>
         <p:nvSpPr>
-          <p:cNvPr id="1" name="PlaceHolder 2"/>
+          <p:cNvPr id="6" name="PlaceHolder 2"/>
           <p:cNvSpPr>
             <a:spLocks noGrp="1"/>
           </p:cNvSpPr>
@@ -438,9 +643,10 @@
           </a:ln>
         </p:spPr>
         <p:txBody>
-          <a:bodyPr lIns="0" rIns="0" tIns="0" bIns="0" anchor="t">
+          <a:bodyPr lIns="0" tIns="0" rIns="0" bIns="0" anchor="t">
             <a:normAutofit/>
           </a:bodyPr>
+          <a:lstStyle/>
           <a:p>
             <a:pPr marL="432000" indent="-324000">
               <a:spcBef>
@@ -454,7 +660,7 @@
               <a:buChar char=""/>
             </a:pPr>
             <a:r>
-              <a:rPr b="0" lang="en-US" sz="3200" spc="-1" strike="noStrike">
+              <a:rPr lang="en-US" sz="3200" b="0" strike="noStrike" spc="-1">
                 <a:solidFill>
                   <a:srgbClr val="000000"/>
                 </a:solidFill>
@@ -462,15 +668,9 @@
               </a:rPr>
               <a:t>Click to edit the outline text format</a:t>
             </a:r>
-            <a:endParaRPr b="0" lang="en-US" sz="3200" spc="-1" strike="noStrike">
-              <a:solidFill>
-                <a:srgbClr val="000000"/>
-              </a:solidFill>
-              <a:latin typeface="Arial"/>
-            </a:endParaRPr>
-          </a:p>
-          <a:p>
-            <a:pPr lvl="1" marL="864000" indent="-324000">
+          </a:p>
+          <a:p>
+            <a:pPr marL="864000" lvl="1" indent="-324000">
               <a:spcBef>
                 <a:spcPts val="1134"/>
               </a:spcBef>
@@ -482,7 +682,7 @@
               <a:buChar char=""/>
             </a:pPr>
             <a:r>
-              <a:rPr b="0" lang="en-US" sz="2800" spc="-1" strike="noStrike">
+              <a:rPr lang="en-US" sz="2800" b="0" strike="noStrike" spc="-1">
                 <a:solidFill>
                   <a:srgbClr val="000000"/>
                 </a:solidFill>
@@ -490,15 +690,9 @@
               </a:rPr>
               <a:t>Second Outline Level</a:t>
             </a:r>
-            <a:endParaRPr b="0" lang="en-US" sz="2800" spc="-1" strike="noStrike">
-              <a:solidFill>
-                <a:srgbClr val="000000"/>
-              </a:solidFill>
-              <a:latin typeface="Arial"/>
-            </a:endParaRPr>
-          </a:p>
-          <a:p>
-            <a:pPr lvl="2" marL="1296000" indent="-288000">
+          </a:p>
+          <a:p>
+            <a:pPr marL="1296000" lvl="2" indent="-288000">
               <a:spcBef>
                 <a:spcPts val="850"/>
               </a:spcBef>
@@ -510,7 +704,7 @@
               <a:buChar char=""/>
             </a:pPr>
             <a:r>
-              <a:rPr b="0" lang="en-US" sz="2400" spc="-1" strike="noStrike">
+              <a:rPr lang="en-US" sz="2400" b="0" strike="noStrike" spc="-1">
                 <a:solidFill>
                   <a:srgbClr val="000000"/>
                 </a:solidFill>
@@ -518,15 +712,9 @@
               </a:rPr>
               <a:t>Third Outline Level</a:t>
             </a:r>
-            <a:endParaRPr b="0" lang="en-US" sz="2400" spc="-1" strike="noStrike">
-              <a:solidFill>
-                <a:srgbClr val="000000"/>
-              </a:solidFill>
-              <a:latin typeface="Arial"/>
-            </a:endParaRPr>
-          </a:p>
-          <a:p>
-            <a:pPr lvl="3" marL="1728000" indent="-216000">
+          </a:p>
+          <a:p>
+            <a:pPr marL="1728000" lvl="3" indent="-216000">
               <a:spcBef>
                 <a:spcPts val="567"/>
               </a:spcBef>
@@ -538,7 +726,7 @@
               <a:buChar char=""/>
             </a:pPr>
             <a:r>
-              <a:rPr b="0" lang="en-US" sz="2000" spc="-1" strike="noStrike">
+              <a:rPr lang="en-US" sz="2000" b="0" strike="noStrike" spc="-1">
                 <a:solidFill>
                   <a:srgbClr val="000000"/>
                 </a:solidFill>
@@ -546,15 +734,9 @@
               </a:rPr>
               <a:t>Fourth Outline Level</a:t>
             </a:r>
-            <a:endParaRPr b="0" lang="en-US" sz="2000" spc="-1" strike="noStrike">
-              <a:solidFill>
-                <a:srgbClr val="000000"/>
-              </a:solidFill>
-              <a:latin typeface="Arial"/>
-            </a:endParaRPr>
-          </a:p>
-          <a:p>
-            <a:pPr lvl="4" marL="2160000" indent="-216000">
+          </a:p>
+          <a:p>
+            <a:pPr marL="2160000" lvl="4" indent="-216000">
               <a:spcBef>
                 <a:spcPts val="283"/>
               </a:spcBef>
@@ -566,7 +748,7 @@
               <a:buChar char=""/>
             </a:pPr>
             <a:r>
-              <a:rPr b="0" lang="en-US" sz="2000" spc="-1" strike="noStrike">
+              <a:rPr lang="en-US" sz="2000" b="0" strike="noStrike" spc="-1">
                 <a:solidFill>
                   <a:srgbClr val="000000"/>
                 </a:solidFill>
@@ -574,15 +756,9 @@
               </a:rPr>
               <a:t>Fifth Outline Level</a:t>
             </a:r>
-            <a:endParaRPr b="0" lang="en-US" sz="2000" spc="-1" strike="noStrike">
-              <a:solidFill>
-                <a:srgbClr val="000000"/>
-              </a:solidFill>
-              <a:latin typeface="Arial"/>
-            </a:endParaRPr>
-          </a:p>
-          <a:p>
-            <a:pPr lvl="5" marL="2592000" indent="-216000">
+          </a:p>
+          <a:p>
+            <a:pPr marL="2592000" lvl="5" indent="-216000">
               <a:spcBef>
                 <a:spcPts val="283"/>
               </a:spcBef>
@@ -594,7 +770,7 @@
               <a:buChar char=""/>
             </a:pPr>
             <a:r>
-              <a:rPr b="0" lang="en-US" sz="2000" spc="-1" strike="noStrike">
+              <a:rPr lang="en-US" sz="2000" b="0" strike="noStrike" spc="-1">
                 <a:solidFill>
                   <a:srgbClr val="000000"/>
                 </a:solidFill>
@@ -602,15 +778,9 @@
               </a:rPr>
               <a:t>Sixth Outline Level</a:t>
             </a:r>
-            <a:endParaRPr b="0" lang="en-US" sz="2000" spc="-1" strike="noStrike">
-              <a:solidFill>
-                <a:srgbClr val="000000"/>
-              </a:solidFill>
-              <a:latin typeface="Arial"/>
-            </a:endParaRPr>
-          </a:p>
-          <a:p>
-            <a:pPr lvl="6" marL="3024000" indent="-216000">
+          </a:p>
+          <a:p>
+            <a:pPr marL="3024000" lvl="6" indent="-216000">
               <a:spcBef>
                 <a:spcPts val="283"/>
               </a:spcBef>
@@ -622,7 +792,7 @@
               <a:buChar char=""/>
             </a:pPr>
             <a:r>
-              <a:rPr b="0" lang="en-US" sz="2000" spc="-1" strike="noStrike">
+              <a:rPr lang="en-US" sz="2000" b="0" strike="noStrike" spc="-1">
                 <a:solidFill>
                   <a:srgbClr val="000000"/>
                 </a:solidFill>
@@ -630,12 +800,6 @@
               </a:rPr>
               <a:t>Seventh Outline Level</a:t>
             </a:r>
-            <a:endParaRPr b="0" lang="en-US" sz="2000" spc="-1" strike="noStrike">
-              <a:solidFill>
-                <a:srgbClr val="000000"/>
-              </a:solidFill>
-              <a:latin typeface="Arial"/>
-            </a:endParaRPr>
           </a:p>
         </p:txBody>
       </p:sp>
@@ -663,13 +827,13 @@
           </a:ln>
         </p:spPr>
         <p:txBody>
-          <a:bodyPr lIns="0" rIns="0" tIns="0" bIns="0" anchor="t">
+          <a:bodyPr lIns="0" tIns="0" rIns="0" bIns="0" anchor="t">
             <a:noAutofit/>
           </a:bodyPr>
           <a:lstStyle>
             <a:lvl1pPr indent="0">
               <a:buNone/>
-              <a:defRPr b="0" lang="en-US" sz="1400" spc="-1" strike="noStrike">
+              <a:defRPr lang="en-US" sz="1400" b="0" strike="noStrike" spc="-1">
                 <a:solidFill>
                   <a:srgbClr val="000000"/>
                 </a:solidFill>
@@ -682,7 +846,7 @@
               <a:buNone/>
             </a:pPr>
             <a:r>
-              <a:rPr b="0" lang="en-US" sz="1400" spc="-1" strike="noStrike">
+              <a:rPr lang="en-US" sz="1400" b="0" strike="noStrike" spc="-1">
                 <a:solidFill>
                   <a:srgbClr val="000000"/>
                 </a:solidFill>
@@ -690,12 +854,6 @@
               </a:rPr>
               <a:t>&lt;date/time&gt;</a:t>
             </a:r>
-            <a:endParaRPr b="0" lang="en-US" sz="1400" spc="-1" strike="noStrike">
-              <a:solidFill>
-                <a:srgbClr val="000000"/>
-              </a:solidFill>
-              <a:latin typeface="Times New Roman"/>
-            </a:endParaRPr>
           </a:p>
         </p:txBody>
       </p:sp>
@@ -723,13 +881,13 @@
           </a:ln>
         </p:spPr>
         <p:txBody>
-          <a:bodyPr lIns="0" rIns="0" tIns="0" bIns="0" anchor="t">
+          <a:bodyPr lIns="0" tIns="0" rIns="0" bIns="0" anchor="t">
             <a:noAutofit/>
           </a:bodyPr>
           <a:lstStyle>
             <a:lvl1pPr indent="0" algn="ctr">
               <a:buNone/>
-              <a:defRPr b="0" lang="en-US" sz="1400" spc="-1" strike="noStrike">
+              <a:defRPr lang="en-US" sz="1400" b="0" strike="noStrike" spc="-1">
                 <a:solidFill>
                   <a:srgbClr val="000000"/>
                 </a:solidFill>
@@ -742,7 +900,7 @@
               <a:buNone/>
             </a:pPr>
             <a:r>
-              <a:rPr b="0" lang="en-US" sz="1400" spc="-1" strike="noStrike">
+              <a:rPr lang="en-US" sz="1400" b="0" strike="noStrike" spc="-1">
                 <a:solidFill>
                   <a:srgbClr val="000000"/>
                 </a:solidFill>
@@ -750,12 +908,6 @@
               </a:rPr>
               <a:t>&lt;footer&gt;</a:t>
             </a:r>
-            <a:endParaRPr b="0" lang="en-US" sz="1400" spc="-1" strike="noStrike">
-              <a:solidFill>
-                <a:srgbClr val="000000"/>
-              </a:solidFill>
-              <a:latin typeface="Times New Roman"/>
-            </a:endParaRPr>
           </a:p>
         </p:txBody>
       </p:sp>
@@ -783,13 +935,13 @@
           </a:ln>
         </p:spPr>
         <p:txBody>
-          <a:bodyPr lIns="0" rIns="0" tIns="0" bIns="0" anchor="t">
+          <a:bodyPr lIns="0" tIns="0" rIns="0" bIns="0" anchor="t">
             <a:noAutofit/>
           </a:bodyPr>
           <a:lstStyle>
             <a:lvl1pPr indent="0" algn="r">
               <a:buNone/>
-              <a:defRPr b="0" lang="en-US" sz="1400" spc="-1" strike="noStrike">
+              <a:defRPr lang="en-US" sz="1400" b="0" strike="noStrike" spc="-1">
                 <a:solidFill>
                   <a:srgbClr val="000000"/>
                 </a:solidFill>
@@ -802,15 +954,15 @@
               <a:buNone/>
             </a:pPr>
             <a:fld id="{C6E33DBF-D0EB-4B80-AD1D-443D0B9B4F4A}" type="slidenum">
-              <a:rPr b="0" lang="en-US" sz="1400" spc="-1" strike="noStrike">
+              <a:rPr lang="en-US" sz="1400" b="0" strike="noStrike" spc="-1">
                 <a:solidFill>
                   <a:srgbClr val="000000"/>
                 </a:solidFill>
                 <a:latin typeface="Times New Roman"/>
               </a:rPr>
-              <a:t>&lt;number&gt;</a:t>
+              <a:t>‹#›</a:t>
             </a:fld>
-            <a:endParaRPr b="0" lang="en-US" sz="1400" spc="-1" strike="noStrike">
+            <a:endParaRPr lang="en-US" sz="1400" b="0" strike="noStrike" spc="-1">
               <a:solidFill>
                 <a:srgbClr val="000000"/>
               </a:solidFill>
@@ -821,16 +973,296 @@
       </p:sp>
     </p:spTree>
   </p:cSld>
-  <p:clrMap bg1="lt1" bg2="lt2" tx1="dk1" tx2="dk2" accent1="accent1" accent2="accent2" accent3="accent3" accent4="accent4" accent5="accent5" accent6="accent6" hlink="hlink" folHlink="folHlink"/>
+  <p:clrMap bg1="lt1" tx1="dk1" bg2="lt2" tx2="dk2" accent1="accent1" accent2="accent2" accent3="accent3" accent4="accent4" accent5="accent5" accent6="accent6" hlink="hlink" folHlink="folHlink"/>
   <p:sldLayoutIdLst>
-    <p:sldLayoutId id="2147483649" r:id="rId2"/>
-    <p:sldLayoutId id="2147483650" r:id="rId3"/>
+    <p:sldLayoutId id="2147483649" r:id="rId1"/>
+    <p:sldLayoutId id="2147483650" r:id="rId2"/>
   </p:sldLayoutIdLst>
+  <p:txStyles>
+    <p:titleStyle>
+      <a:lvl1pPr algn="l" defTabSz="914400" rtl="0" eaLnBrk="1" latinLnBrk="0" hangingPunct="1">
+        <a:lnSpc>
+          <a:spcPct val="90000"/>
+        </a:lnSpc>
+        <a:spcBef>
+          <a:spcPct val="0"/>
+        </a:spcBef>
+        <a:buNone/>
+        <a:defRPr sz="4400" kern="1200">
+          <a:solidFill>
+            <a:schemeClr val="tx1"/>
+          </a:solidFill>
+          <a:latin typeface="+mj-lt"/>
+          <a:ea typeface="+mj-ea"/>
+          <a:cs typeface="+mj-cs"/>
+        </a:defRPr>
+      </a:lvl1pPr>
+    </p:titleStyle>
+    <p:bodyStyle>
+      <a:lvl1pPr marL="228600" indent="-228600" algn="l" defTabSz="914400" rtl="0" eaLnBrk="1" latinLnBrk="0" hangingPunct="1">
+        <a:lnSpc>
+          <a:spcPct val="90000"/>
+        </a:lnSpc>
+        <a:spcBef>
+          <a:spcPts val="1000"/>
+        </a:spcBef>
+        <a:buFont typeface="Arial" panose="020B0604020202020204" pitchFamily="34" charset="0"/>
+        <a:buChar char="•"/>
+        <a:defRPr sz="2800" kern="1200">
+          <a:solidFill>
+            <a:schemeClr val="tx1"/>
+          </a:solidFill>
+          <a:latin typeface="+mn-lt"/>
+          <a:ea typeface="+mn-ea"/>
+          <a:cs typeface="+mn-cs"/>
+        </a:defRPr>
+      </a:lvl1pPr>
+      <a:lvl2pPr marL="685800" indent="-228600" algn="l" defTabSz="914400" rtl="0" eaLnBrk="1" latinLnBrk="0" hangingPunct="1">
+        <a:lnSpc>
+          <a:spcPct val="90000"/>
+        </a:lnSpc>
+        <a:spcBef>
+          <a:spcPts val="500"/>
+        </a:spcBef>
+        <a:buFont typeface="Arial" panose="020B0604020202020204" pitchFamily="34" charset="0"/>
+        <a:buChar char="•"/>
+        <a:defRPr sz="2400" kern="1200">
+          <a:solidFill>
+            <a:schemeClr val="tx1"/>
+          </a:solidFill>
+          <a:latin typeface="+mn-lt"/>
+          <a:ea typeface="+mn-ea"/>
+          <a:cs typeface="+mn-cs"/>
+        </a:defRPr>
+      </a:lvl2pPr>
+      <a:lvl3pPr marL="1143000" indent="-228600" algn="l" defTabSz="914400" rtl="0" eaLnBrk="1" latinLnBrk="0" hangingPunct="1">
+        <a:lnSpc>
+          <a:spcPct val="90000"/>
+        </a:lnSpc>
+        <a:spcBef>
+          <a:spcPts val="500"/>
+        </a:spcBef>
+        <a:buFont typeface="Arial" panose="020B0604020202020204" pitchFamily="34" charset="0"/>
+        <a:buChar char="•"/>
+        <a:defRPr sz="2000" kern="1200">
+          <a:solidFill>
+            <a:schemeClr val="tx1"/>
+          </a:solidFill>
+          <a:latin typeface="+mn-lt"/>
+          <a:ea typeface="+mn-ea"/>
+          <a:cs typeface="+mn-cs"/>
+        </a:defRPr>
+      </a:lvl3pPr>
+      <a:lvl4pPr marL="1600200" indent="-228600" algn="l" defTabSz="914400" rtl="0" eaLnBrk="1" latinLnBrk="0" hangingPunct="1">
+        <a:lnSpc>
+          <a:spcPct val="90000"/>
+        </a:lnSpc>
+        <a:spcBef>
+          <a:spcPts val="500"/>
+        </a:spcBef>
+        <a:buFont typeface="Arial" panose="020B0604020202020204" pitchFamily="34" charset="0"/>
+        <a:buChar char="•"/>
+        <a:defRPr sz="1800" kern="1200">
+          <a:solidFill>
+            <a:schemeClr val="tx1"/>
+          </a:solidFill>
+          <a:latin typeface="+mn-lt"/>
+          <a:ea typeface="+mn-ea"/>
+          <a:cs typeface="+mn-cs"/>
+        </a:defRPr>
+      </a:lvl4pPr>
+      <a:lvl5pPr marL="2057400" indent="-228600" algn="l" defTabSz="914400" rtl="0" eaLnBrk="1" latinLnBrk="0" hangingPunct="1">
+        <a:lnSpc>
+          <a:spcPct val="90000"/>
+        </a:lnSpc>
+        <a:spcBef>
+          <a:spcPts val="500"/>
+        </a:spcBef>
+        <a:buFont typeface="Arial" panose="020B0604020202020204" pitchFamily="34" charset="0"/>
+        <a:buChar char="•"/>
+        <a:defRPr sz="1800" kern="1200">
+          <a:solidFill>
+            <a:schemeClr val="tx1"/>
+          </a:solidFill>
+          <a:latin typeface="+mn-lt"/>
+          <a:ea typeface="+mn-ea"/>
+          <a:cs typeface="+mn-cs"/>
+        </a:defRPr>
+      </a:lvl5pPr>
+      <a:lvl6pPr marL="2514600" indent="-228600" algn="l" defTabSz="914400" rtl="0" eaLnBrk="1" latinLnBrk="0" hangingPunct="1">
+        <a:lnSpc>
+          <a:spcPct val="90000"/>
+        </a:lnSpc>
+        <a:spcBef>
+          <a:spcPts val="500"/>
+        </a:spcBef>
+        <a:buFont typeface="Arial" panose="020B0604020202020204" pitchFamily="34" charset="0"/>
+        <a:buChar char="•"/>
+        <a:defRPr sz="1800" kern="1200">
+          <a:solidFill>
+            <a:schemeClr val="tx1"/>
+          </a:solidFill>
+          <a:latin typeface="+mn-lt"/>
+          <a:ea typeface="+mn-ea"/>
+          <a:cs typeface="+mn-cs"/>
+        </a:defRPr>
+      </a:lvl6pPr>
+      <a:lvl7pPr marL="2971800" indent="-228600" algn="l" defTabSz="914400" rtl="0" eaLnBrk="1" latinLnBrk="0" hangingPunct="1">
+        <a:lnSpc>
+          <a:spcPct val="90000"/>
+        </a:lnSpc>
+        <a:spcBef>
+          <a:spcPts val="500"/>
+        </a:spcBef>
+        <a:buFont typeface="Arial" panose="020B0604020202020204" pitchFamily="34" charset="0"/>
+        <a:buChar char="•"/>
+        <a:defRPr sz="1800" kern="1200">
+          <a:solidFill>
+            <a:schemeClr val="tx1"/>
+          </a:solidFill>
+          <a:latin typeface="+mn-lt"/>
+          <a:ea typeface="+mn-ea"/>
+          <a:cs typeface="+mn-cs"/>
+        </a:defRPr>
+      </a:lvl7pPr>
+      <a:lvl8pPr marL="3429000" indent="-228600" algn="l" defTabSz="914400" rtl="0" eaLnBrk="1" latinLnBrk="0" hangingPunct="1">
+        <a:lnSpc>
+          <a:spcPct val="90000"/>
+        </a:lnSpc>
+        <a:spcBef>
+          <a:spcPts val="500"/>
+        </a:spcBef>
+        <a:buFont typeface="Arial" panose="020B0604020202020204" pitchFamily="34" charset="0"/>
+        <a:buChar char="•"/>
+        <a:defRPr sz="1800" kern="1200">
+          <a:solidFill>
+            <a:schemeClr val="tx1"/>
+          </a:solidFill>
+          <a:latin typeface="+mn-lt"/>
+          <a:ea typeface="+mn-ea"/>
+          <a:cs typeface="+mn-cs"/>
+        </a:defRPr>
+      </a:lvl8pPr>
+      <a:lvl9pPr marL="3886200" indent="-228600" algn="l" defTabSz="914400" rtl="0" eaLnBrk="1" latinLnBrk="0" hangingPunct="1">
+        <a:lnSpc>
+          <a:spcPct val="90000"/>
+        </a:lnSpc>
+        <a:spcBef>
+          <a:spcPts val="500"/>
+        </a:spcBef>
+        <a:buFont typeface="Arial" panose="020B0604020202020204" pitchFamily="34" charset="0"/>
+        <a:buChar char="•"/>
+        <a:defRPr sz="1800" kern="1200">
+          <a:solidFill>
+            <a:schemeClr val="tx1"/>
+          </a:solidFill>
+          <a:latin typeface="+mn-lt"/>
+          <a:ea typeface="+mn-ea"/>
+          <a:cs typeface="+mn-cs"/>
+        </a:defRPr>
+      </a:lvl9pPr>
+    </p:bodyStyle>
+    <p:otherStyle>
+      <a:defPPr>
+        <a:defRPr lang="en-SI"/>
+      </a:defPPr>
+      <a:lvl1pPr marL="0" algn="l" defTabSz="914400" rtl="0" eaLnBrk="1" latinLnBrk="0" hangingPunct="1">
+        <a:defRPr sz="1800" kern="1200">
+          <a:solidFill>
+            <a:schemeClr val="tx1"/>
+          </a:solidFill>
+          <a:latin typeface="+mn-lt"/>
+          <a:ea typeface="+mn-ea"/>
+          <a:cs typeface="+mn-cs"/>
+        </a:defRPr>
+      </a:lvl1pPr>
+      <a:lvl2pPr marL="457200" algn="l" defTabSz="914400" rtl="0" eaLnBrk="1" latinLnBrk="0" hangingPunct="1">
+        <a:defRPr sz="1800" kern="1200">
+          <a:solidFill>
+            <a:schemeClr val="tx1"/>
+          </a:solidFill>
+          <a:latin typeface="+mn-lt"/>
+          <a:ea typeface="+mn-ea"/>
+          <a:cs typeface="+mn-cs"/>
+        </a:defRPr>
+      </a:lvl2pPr>
+      <a:lvl3pPr marL="914400" algn="l" defTabSz="914400" rtl="0" eaLnBrk="1" latinLnBrk="0" hangingPunct="1">
+        <a:defRPr sz="1800" kern="1200">
+          <a:solidFill>
+            <a:schemeClr val="tx1"/>
+          </a:solidFill>
+          <a:latin typeface="+mn-lt"/>
+          <a:ea typeface="+mn-ea"/>
+          <a:cs typeface="+mn-cs"/>
+        </a:defRPr>
+      </a:lvl3pPr>
+      <a:lvl4pPr marL="1371600" algn="l" defTabSz="914400" rtl="0" eaLnBrk="1" latinLnBrk="0" hangingPunct="1">
+        <a:defRPr sz="1800" kern="1200">
+          <a:solidFill>
+            <a:schemeClr val="tx1"/>
+          </a:solidFill>
+          <a:latin typeface="+mn-lt"/>
+          <a:ea typeface="+mn-ea"/>
+          <a:cs typeface="+mn-cs"/>
+        </a:defRPr>
+      </a:lvl4pPr>
+      <a:lvl5pPr marL="1828800" algn="l" defTabSz="914400" rtl="0" eaLnBrk="1" latinLnBrk="0" hangingPunct="1">
+        <a:defRPr sz="1800" kern="1200">
+          <a:solidFill>
+            <a:schemeClr val="tx1"/>
+          </a:solidFill>
+          <a:latin typeface="+mn-lt"/>
+          <a:ea typeface="+mn-ea"/>
+          <a:cs typeface="+mn-cs"/>
+        </a:defRPr>
+      </a:lvl5pPr>
+      <a:lvl6pPr marL="2286000" algn="l" defTabSz="914400" rtl="0" eaLnBrk="1" latinLnBrk="0" hangingPunct="1">
+        <a:defRPr sz="1800" kern="1200">
+          <a:solidFill>
+            <a:schemeClr val="tx1"/>
+          </a:solidFill>
+          <a:latin typeface="+mn-lt"/>
+          <a:ea typeface="+mn-ea"/>
+          <a:cs typeface="+mn-cs"/>
+        </a:defRPr>
+      </a:lvl6pPr>
+      <a:lvl7pPr marL="2743200" algn="l" defTabSz="914400" rtl="0" eaLnBrk="1" latinLnBrk="0" hangingPunct="1">
+        <a:defRPr sz="1800" kern="1200">
+          <a:solidFill>
+            <a:schemeClr val="tx1"/>
+          </a:solidFill>
+          <a:latin typeface="+mn-lt"/>
+          <a:ea typeface="+mn-ea"/>
+          <a:cs typeface="+mn-cs"/>
+        </a:defRPr>
+      </a:lvl7pPr>
+      <a:lvl8pPr marL="3200400" algn="l" defTabSz="914400" rtl="0" eaLnBrk="1" latinLnBrk="0" hangingPunct="1">
+        <a:defRPr sz="1800" kern="1200">
+          <a:solidFill>
+            <a:schemeClr val="tx1"/>
+          </a:solidFill>
+          <a:latin typeface="+mn-lt"/>
+          <a:ea typeface="+mn-ea"/>
+          <a:cs typeface="+mn-cs"/>
+        </a:defRPr>
+      </a:lvl8pPr>
+      <a:lvl9pPr marL="3657600" algn="l" defTabSz="914400" rtl="0" eaLnBrk="1" latinLnBrk="0" hangingPunct="1">
+        <a:defRPr sz="1800" kern="1200">
+          <a:solidFill>
+            <a:schemeClr val="tx1"/>
+          </a:solidFill>
+          <a:latin typeface="+mn-lt"/>
+          <a:ea typeface="+mn-ea"/>
+          <a:cs typeface="+mn-cs"/>
+        </a:defRPr>
+      </a:lvl9pPr>
+    </p:otherStyle>
+  </p:txStyles>
 </p:sldMaster>
 </file>
 
 <file path=ppt/slides/slide1.xml><?xml version="1.0" encoding="utf-8"?>
-<p:sld xmlns:a="http://schemas.openxmlformats.org/drawingml/2006/main" xmlns:p="http://schemas.openxmlformats.org/presentationml/2006/main" xmlns:r="http://schemas.openxmlformats.org/officeDocument/2006/relationships" xmlns:p14="http://schemas.microsoft.com/office/powerpoint/2010/main" xmlns:p15="http://schemas.microsoft.com/office/powerpoint/2012/main" xmlns:mc="http://schemas.openxmlformats.org/markup-compatibility/2006">
+<p:sld xmlns:a="http://schemas.openxmlformats.org/drawingml/2006/main" xmlns:r="http://schemas.openxmlformats.org/officeDocument/2006/relationships" xmlns:p="http://schemas.openxmlformats.org/presentationml/2006/main">
   <p:cSld>
     <p:spTree>
       <p:nvGrpSpPr>
@@ -870,15 +1302,16 @@
           </a:ln>
         </p:spPr>
         <p:txBody>
-          <a:bodyPr lIns="0" rIns="0" tIns="0" bIns="0" anchor="ctr">
+          <a:bodyPr lIns="0" tIns="0" rIns="0" bIns="0" anchor="ctr">
             <a:noAutofit/>
           </a:bodyPr>
+          <a:lstStyle/>
           <a:p>
             <a:pPr indent="0" algn="ctr">
               <a:buNone/>
             </a:pPr>
             <a:r>
-              <a:rPr b="0" lang="en-US" sz="4400" spc="-1" strike="noStrike">
+              <a:rPr lang="en-US" sz="4400" b="0" strike="noStrike" spc="-1">
                 <a:solidFill>
                   <a:srgbClr val="000000"/>
                 </a:solidFill>
@@ -886,12 +1319,6 @@
               </a:rPr>
               <a:t>Governor</a:t>
             </a:r>
-            <a:endParaRPr b="0" lang="en-US" sz="4400" spc="-1" strike="noStrike">
-              <a:solidFill>
-                <a:srgbClr val="000000"/>
-              </a:solidFill>
-              <a:latin typeface="Arial"/>
-            </a:endParaRPr>
           </a:p>
         </p:txBody>
       </p:sp>
@@ -919,15 +1346,16 @@
           </a:ln>
         </p:spPr>
         <p:txBody>
-          <a:bodyPr lIns="0" rIns="0" tIns="0" bIns="0" anchor="ctr">
+          <a:bodyPr lIns="0" tIns="0" rIns="0" bIns="0" anchor="ctr">
             <a:noAutofit/>
           </a:bodyPr>
+          <a:lstStyle/>
           <a:p>
             <a:pPr indent="0" algn="ctr">
               <a:buNone/>
             </a:pPr>
             <a:r>
-              <a:rPr b="0" lang="en-US" sz="2200" spc="-1" strike="noStrike">
+              <a:rPr lang="en-US" sz="2200" b="0" strike="noStrike" spc="-1" dirty="0">
                 <a:solidFill>
                   <a:srgbClr val="000000"/>
                 </a:solidFill>
@@ -935,7 +1363,12 @@
               </a:rPr>
               <a:t>Adam Rakun &amp; Matteo D’Urso</a:t>
             </a:r>
-            <a:endParaRPr b="0" lang="en-US" sz="2200" spc="-1" strike="noStrike">
+          </a:p>
+          <a:p>
+            <a:pPr indent="0" algn="ctr">
+              <a:buNone/>
+            </a:pPr>
+            <a:endParaRPr lang="en-US" sz="1800" b="0" strike="noStrike" spc="-1" dirty="0">
               <a:solidFill>
                 <a:srgbClr val="000000"/>
               </a:solidFill>
@@ -946,7 +1379,7 @@
             <a:pPr indent="0" algn="ctr">
               <a:buNone/>
             </a:pPr>
-            <a:endParaRPr b="0" lang="en-US" sz="1800" spc="-1" strike="noStrike">
+            <a:endParaRPr lang="en-US" sz="1800" b="0" strike="noStrike" spc="-1" dirty="0">
               <a:solidFill>
                 <a:srgbClr val="000000"/>
               </a:solidFill>
@@ -957,39 +1390,22 @@
             <a:pPr indent="0" algn="ctr">
               <a:buNone/>
             </a:pPr>
-            <a:endParaRPr b="0" lang="en-US" sz="1800" spc="-1" strike="noStrike">
-              <a:solidFill>
-                <a:srgbClr val="000000"/>
-              </a:solidFill>
-              <a:latin typeface="Arial"/>
-            </a:endParaRPr>
+            <a:r>
+              <a:rPr lang="en-US" sz="1800" b="0" strike="noStrike" spc="-1" dirty="0">
+                <a:solidFill>
+                  <a:srgbClr val="000000"/>
+                </a:solidFill>
+                <a:latin typeface="Arial"/>
+              </a:rPr>
+              <a:t>Embedded Systems (5063EMSY6Y)</a:t>
+            </a:r>
           </a:p>
           <a:p>
             <a:pPr indent="0" algn="ctr">
               <a:buNone/>
             </a:pPr>
             <a:r>
-              <a:rPr b="0" lang="en-US" sz="1800" spc="-1" strike="noStrike">
-                <a:solidFill>
-                  <a:srgbClr val="000000"/>
-                </a:solidFill>
-                <a:latin typeface="Arial"/>
-              </a:rPr>
-              <a:t>Embedded Systems (5063EMSY6Y)</a:t>
-            </a:r>
-            <a:endParaRPr b="0" lang="en-US" sz="1800" spc="-1" strike="noStrike">
-              <a:solidFill>
-                <a:srgbClr val="000000"/>
-              </a:solidFill>
-              <a:latin typeface="Arial"/>
-            </a:endParaRPr>
-          </a:p>
-          <a:p>
-            <a:pPr indent="0" algn="ctr">
-              <a:buNone/>
-            </a:pPr>
-            <a:r>
-              <a:rPr b="0" lang="en-US" sz="1800" spc="-1" strike="noStrike">
+              <a:rPr lang="en-US" sz="1800" b="0" strike="noStrike" spc="-1" dirty="0">
                 <a:solidFill>
                   <a:srgbClr val="000000"/>
                 </a:solidFill>
@@ -997,24 +1413,18 @@
               </a:rPr>
               <a:t>A. Pathania, H. Xu</a:t>
             </a:r>
-            <a:endParaRPr b="0" lang="en-US" sz="1800" spc="-1" strike="noStrike">
-              <a:solidFill>
-                <a:srgbClr val="000000"/>
-              </a:solidFill>
-              <a:latin typeface="Arial"/>
-            </a:endParaRPr>
           </a:p>
         </p:txBody>
       </p:sp>
       <p:pic>
         <p:nvPicPr>
-          <p:cNvPr id="11" name="" descr=""/>
+          <p:cNvPr id="11" name="Picture 10"/>
           <p:cNvPicPr/>
           <p:nvPr/>
         </p:nvPicPr>
         <p:blipFill>
-          <a:blip r:embed="rId1"/>
-          <a:srcRect l="0" t="7261" r="0" b="0"/>
+          <a:blip r:embed="rId2"/>
+          <a:srcRect t="7261"/>
           <a:stretch/>
         </p:blipFill>
         <p:spPr>
@@ -1032,12 +1442,12 @@
       </p:pic>
       <p:pic>
         <p:nvPicPr>
-          <p:cNvPr id="12" name="" descr=""/>
+          <p:cNvPr id="12" name="Picture 11"/>
           <p:cNvPicPr/>
           <p:nvPr/>
         </p:nvPicPr>
         <p:blipFill>
-          <a:blip r:embed="rId2"/>
+          <a:blip r:embed="rId3"/>
           <a:stretch/>
         </p:blipFill>
         <p:spPr>
@@ -1055,19 +1465,14 @@
       </p:pic>
     </p:spTree>
   </p:cSld>
-  <mc:AlternateContent>
-    <mc:Choice Requires="p14">
-      <p:transition spd="slow" p14:dur="2000"/>
-    </mc:Choice>
-    <mc:Fallback>
-      <p:transition spd="slow"/>
-    </mc:Fallback>
-  </mc:AlternateContent>
+  <p:clrMapOvr>
+    <a:masterClrMapping/>
+  </p:clrMapOvr>
 </p:sld>
 </file>
 
 <file path=ppt/slides/slide2.xml><?xml version="1.0" encoding="utf-8"?>
-<p:sld xmlns:a="http://schemas.openxmlformats.org/drawingml/2006/main" xmlns:p="http://schemas.openxmlformats.org/presentationml/2006/main" xmlns:r="http://schemas.openxmlformats.org/officeDocument/2006/relationships" xmlns:p14="http://schemas.microsoft.com/office/powerpoint/2010/main" xmlns:p15="http://schemas.microsoft.com/office/powerpoint/2012/main" xmlns:mc="http://schemas.openxmlformats.org/markup-compatibility/2006">
+<p:sld xmlns:a="http://schemas.openxmlformats.org/drawingml/2006/main" xmlns:r="http://schemas.openxmlformats.org/officeDocument/2006/relationships" xmlns:p="http://schemas.openxmlformats.org/presentationml/2006/main">
   <p:cSld>
     <p:spTree>
       <p:nvGrpSpPr>
@@ -1107,37 +1512,23 @@
           </a:ln>
         </p:spPr>
         <p:txBody>
-          <a:bodyPr lIns="0" rIns="0" tIns="0" bIns="0" anchor="ctr">
+          <a:bodyPr lIns="0" tIns="0" rIns="0" bIns="0" anchor="ctr">
             <a:noAutofit/>
           </a:bodyPr>
+          <a:lstStyle/>
           <a:p>
             <a:pPr indent="0" algn="ctr">
               <a:buNone/>
             </a:pPr>
             <a:r>
-              <a:rPr b="0" lang="en-US" sz="4400" spc="-1" strike="noStrike">
-                <a:solidFill>
-                  <a:srgbClr val="000000"/>
-                </a:solidFill>
-                <a:latin typeface="Arial"/>
-              </a:rPr>
-              <a:t>Index</a:t>
-            </a:r>
-            <a:r>
-              <a:rPr b="0" lang="en-US" sz="4400" spc="-1" strike="noStrike">
-                <a:solidFill>
-                  <a:srgbClr val="000000"/>
-                </a:solidFill>
-                <a:latin typeface="Arial"/>
-              </a:rPr>
-              <a:t>	</a:t>
-            </a:r>
-            <a:endParaRPr b="0" lang="en-US" sz="4400" spc="-1" strike="noStrike">
-              <a:solidFill>
-                <a:srgbClr val="000000"/>
-              </a:solidFill>
-              <a:latin typeface="Arial"/>
-            </a:endParaRPr>
+              <a:rPr lang="en-US" sz="4400" b="0" strike="noStrike" spc="-1">
+                <a:solidFill>
+                  <a:srgbClr val="000000"/>
+                </a:solidFill>
+                <a:latin typeface="Arial"/>
+              </a:rPr>
+              <a:t>Index	</a:t>
+            </a:r>
           </a:p>
         </p:txBody>
       </p:sp>
@@ -1165,9 +1556,10 @@
           </a:ln>
         </p:spPr>
         <p:txBody>
-          <a:bodyPr lIns="0" rIns="0" tIns="0" bIns="0" anchor="t">
-            <a:normAutofit fontScale="87491"/>
+          <a:bodyPr lIns="0" tIns="0" rIns="0" bIns="0" anchor="t">
+            <a:normAutofit fontScale="94991" lnSpcReduction="10000"/>
           </a:bodyPr>
+          <a:lstStyle/>
           <a:p>
             <a:pPr marL="432000" indent="-324000">
               <a:spcBef>
@@ -1180,29 +1572,14 @@
               <a:buAutoNum type="arabicPeriod"/>
             </a:pPr>
             <a:r>
-              <a:rPr b="0" lang="en-US" sz="3200" spc="-1" strike="noStrike">
-                <a:solidFill>
-                  <a:srgbClr val="000000"/>
-                </a:solidFill>
-                <a:latin typeface="Arial"/>
-              </a:rPr>
-              <a:t> </a:t>
-            </a:r>
-            <a:r>
-              <a:rPr b="0" lang="en-US" sz="3200" spc="-1" strike="noStrike">
-                <a:solidFill>
-                  <a:srgbClr val="000000"/>
-                </a:solidFill>
-                <a:latin typeface="Arial"/>
-              </a:rPr>
-              <a:t>Overall Structure</a:t>
-            </a:r>
-            <a:endParaRPr b="0" lang="en-US" sz="3200" spc="-1" strike="noStrike">
-              <a:solidFill>
-                <a:srgbClr val="000000"/>
-              </a:solidFill>
-              <a:latin typeface="Arial"/>
-            </a:endParaRPr>
+              <a:rPr lang="en-US" sz="3200" b="0" strike="noStrike" spc="-1">
+                <a:solidFill>
+                  <a:srgbClr val="000000"/>
+                </a:solidFill>
+                <a:latin typeface="Arial"/>
+              </a:rPr>
+              <a:t> Overall Structure</a:t>
+            </a:r>
           </a:p>
           <a:p>
             <a:pPr marL="432000" indent="-324000">
@@ -1216,29 +1593,14 @@
               <a:buAutoNum type="arabicPeriod"/>
             </a:pPr>
             <a:r>
-              <a:rPr b="0" lang="en-US" sz="3200" spc="-1" strike="noStrike">
-                <a:solidFill>
-                  <a:srgbClr val="000000"/>
-                </a:solidFill>
-                <a:latin typeface="Arial"/>
-              </a:rPr>
-              <a:t> </a:t>
-            </a:r>
-            <a:r>
-              <a:rPr b="0" lang="en-US" sz="3200" spc="-1" strike="noStrike">
-                <a:solidFill>
-                  <a:srgbClr val="000000"/>
-                </a:solidFill>
-                <a:latin typeface="Arial"/>
-              </a:rPr>
-              <a:t>Design-Time: Look-Up table</a:t>
-            </a:r>
-            <a:endParaRPr b="0" lang="en-US" sz="3200" spc="-1" strike="noStrike">
-              <a:solidFill>
-                <a:srgbClr val="000000"/>
-              </a:solidFill>
-              <a:latin typeface="Arial"/>
-            </a:endParaRPr>
+              <a:rPr lang="en-US" sz="3200" b="0" strike="noStrike" spc="-1">
+                <a:solidFill>
+                  <a:srgbClr val="000000"/>
+                </a:solidFill>
+                <a:latin typeface="Arial"/>
+              </a:rPr>
+              <a:t> Design-Time: Look-Up table</a:t>
+            </a:r>
           </a:p>
           <a:p>
             <a:pPr marL="432000" indent="-324000">
@@ -1252,29 +1614,14 @@
               <a:buAutoNum type="arabicPeriod"/>
             </a:pPr>
             <a:r>
-              <a:rPr b="0" lang="en-US" sz="3200" spc="-1" strike="noStrike">
-                <a:solidFill>
-                  <a:srgbClr val="000000"/>
-                </a:solidFill>
-                <a:latin typeface="Arial"/>
-              </a:rPr>
-              <a:t> </a:t>
-            </a:r>
-            <a:r>
-              <a:rPr b="0" lang="en-US" sz="3200" spc="-1" strike="noStrike">
-                <a:solidFill>
-                  <a:srgbClr val="000000"/>
-                </a:solidFill>
-                <a:latin typeface="Arial"/>
-              </a:rPr>
-              <a:t>Run-Time: MIMO PID-Controller</a:t>
-            </a:r>
-            <a:endParaRPr b="0" lang="en-US" sz="3200" spc="-1" strike="noStrike">
-              <a:solidFill>
-                <a:srgbClr val="000000"/>
-              </a:solidFill>
-              <a:latin typeface="Arial"/>
-            </a:endParaRPr>
+              <a:rPr lang="en-US" sz="3200" b="0" strike="noStrike" spc="-1">
+                <a:solidFill>
+                  <a:srgbClr val="000000"/>
+                </a:solidFill>
+                <a:latin typeface="Arial"/>
+              </a:rPr>
+              <a:t> Run-Time: MIMO PID-Controller</a:t>
+            </a:r>
           </a:p>
           <a:p>
             <a:pPr marL="432000" indent="-324000">
@@ -1288,29 +1635,14 @@
               <a:buAutoNum type="arabicPeriod"/>
             </a:pPr>
             <a:r>
-              <a:rPr b="0" lang="en-US" sz="3200" spc="-1" strike="noStrike">
-                <a:solidFill>
-                  <a:srgbClr val="000000"/>
-                </a:solidFill>
-                <a:latin typeface="Arial"/>
-              </a:rPr>
-              <a:t> </a:t>
-            </a:r>
-            <a:r>
-              <a:rPr b="0" lang="en-US" sz="3200" spc="-1" strike="noStrike">
-                <a:solidFill>
-                  <a:srgbClr val="000000"/>
-                </a:solidFill>
-                <a:latin typeface="Arial"/>
-              </a:rPr>
-              <a:t>PID Controller</a:t>
-            </a:r>
-            <a:endParaRPr b="0" lang="en-US" sz="3200" spc="-1" strike="noStrike">
-              <a:solidFill>
-                <a:srgbClr val="000000"/>
-              </a:solidFill>
-              <a:latin typeface="Arial"/>
-            </a:endParaRPr>
+              <a:rPr lang="en-US" sz="3200" b="0" strike="noStrike" spc="-1">
+                <a:solidFill>
+                  <a:srgbClr val="000000"/>
+                </a:solidFill>
+                <a:latin typeface="Arial"/>
+              </a:rPr>
+              <a:t> PID Controller</a:t>
+            </a:r>
           </a:p>
           <a:p>
             <a:pPr marL="432000" indent="-324000">
@@ -1324,29 +1656,14 @@
               <a:buAutoNum type="arabicPeriod"/>
             </a:pPr>
             <a:r>
-              <a:rPr b="0" lang="en-US" sz="3200" spc="-1" strike="noStrike">
-                <a:solidFill>
-                  <a:srgbClr val="000000"/>
-                </a:solidFill>
-                <a:latin typeface="Arial"/>
-              </a:rPr>
-              <a:t> </a:t>
-            </a:r>
-            <a:r>
-              <a:rPr b="0" lang="en-US" sz="3200" spc="-1" strike="noStrike">
-                <a:solidFill>
-                  <a:srgbClr val="000000"/>
-                </a:solidFill>
-                <a:latin typeface="Arial"/>
-              </a:rPr>
-              <a:t>PID Decisions</a:t>
-            </a:r>
-            <a:endParaRPr b="0" lang="en-US" sz="3200" spc="-1" strike="noStrike">
-              <a:solidFill>
-                <a:srgbClr val="000000"/>
-              </a:solidFill>
-              <a:latin typeface="Arial"/>
-            </a:endParaRPr>
+              <a:rPr lang="en-US" sz="3200" b="0" strike="noStrike" spc="-1">
+                <a:solidFill>
+                  <a:srgbClr val="000000"/>
+                </a:solidFill>
+                <a:latin typeface="Arial"/>
+              </a:rPr>
+              <a:t> PID Decisions</a:t>
+            </a:r>
           </a:p>
           <a:p>
             <a:pPr marL="432000" indent="-324000">
@@ -1360,47 +1677,27 @@
               <a:buAutoNum type="arabicPeriod"/>
             </a:pPr>
             <a:r>
-              <a:rPr b="0" lang="en-US" sz="3200" spc="-1" strike="noStrike">
-                <a:solidFill>
-                  <a:srgbClr val="000000"/>
-                </a:solidFill>
-                <a:latin typeface="Arial"/>
-              </a:rPr>
-              <a:t> </a:t>
-            </a:r>
-            <a:r>
-              <a:rPr b="0" lang="en-US" sz="3200" spc="-1" strike="noStrike">
-                <a:solidFill>
-                  <a:srgbClr val="000000"/>
-                </a:solidFill>
-                <a:latin typeface="Arial"/>
-              </a:rPr>
-              <a:t>Power Estimation Model</a:t>
-            </a:r>
-            <a:endParaRPr b="0" lang="en-US" sz="3200" spc="-1" strike="noStrike">
-              <a:solidFill>
-                <a:srgbClr val="000000"/>
-              </a:solidFill>
-              <a:latin typeface="Arial"/>
-            </a:endParaRPr>
+              <a:rPr lang="en-US" sz="3200" b="0" strike="noStrike" spc="-1">
+                <a:solidFill>
+                  <a:srgbClr val="000000"/>
+                </a:solidFill>
+                <a:latin typeface="Arial"/>
+              </a:rPr>
+              <a:t> Power Estimation Model</a:t>
+            </a:r>
           </a:p>
         </p:txBody>
       </p:sp>
     </p:spTree>
   </p:cSld>
-  <mc:AlternateContent>
-    <mc:Choice Requires="p14">
-      <p:transition spd="slow" p14:dur="2000"/>
-    </mc:Choice>
-    <mc:Fallback>
-      <p:transition spd="slow"/>
-    </mc:Fallback>
-  </mc:AlternateContent>
+  <p:clrMapOvr>
+    <a:masterClrMapping/>
+  </p:clrMapOvr>
 </p:sld>
 </file>
 
 <file path=ppt/slides/slide3.xml><?xml version="1.0" encoding="utf-8"?>
-<p:sld xmlns:a="http://schemas.openxmlformats.org/drawingml/2006/main" xmlns:p="http://schemas.openxmlformats.org/presentationml/2006/main" xmlns:r="http://schemas.openxmlformats.org/officeDocument/2006/relationships" xmlns:p14="http://schemas.microsoft.com/office/powerpoint/2010/main" xmlns:p15="http://schemas.microsoft.com/office/powerpoint/2012/main" xmlns:mc="http://schemas.openxmlformats.org/markup-compatibility/2006">
+<p:sld xmlns:a="http://schemas.openxmlformats.org/drawingml/2006/main" xmlns:r="http://schemas.openxmlformats.org/officeDocument/2006/relationships" xmlns:p="http://schemas.openxmlformats.org/presentationml/2006/main">
   <p:cSld>
     <p:spTree>
       <p:nvGrpSpPr>
@@ -1440,15 +1737,16 @@
           </a:ln>
         </p:spPr>
         <p:txBody>
-          <a:bodyPr lIns="0" rIns="0" tIns="0" bIns="0" anchor="ctr">
+          <a:bodyPr lIns="0" tIns="0" rIns="0" bIns="0" anchor="ctr">
             <a:noAutofit/>
           </a:bodyPr>
+          <a:lstStyle/>
           <a:p>
             <a:pPr indent="0" algn="ctr">
               <a:buNone/>
             </a:pPr>
             <a:r>
-              <a:rPr b="0" lang="en-US" sz="4400" spc="-1" strike="noStrike">
+              <a:rPr lang="en-US" sz="4400" b="0" strike="noStrike" spc="-1">
                 <a:solidFill>
                   <a:srgbClr val="000000"/>
                 </a:solidFill>
@@ -1456,12 +1754,6 @@
               </a:rPr>
               <a:t>Overall structure</a:t>
             </a:r>
-            <a:endParaRPr b="0" lang="en-US" sz="4400" spc="-1" strike="noStrike">
-              <a:solidFill>
-                <a:srgbClr val="000000"/>
-              </a:solidFill>
-              <a:latin typeface="Arial"/>
-            </a:endParaRPr>
           </a:p>
         </p:txBody>
       </p:sp>
@@ -1489,9 +1781,10 @@
           </a:ln>
         </p:spPr>
         <p:txBody>
-          <a:bodyPr lIns="0" rIns="0" tIns="0" bIns="0" anchor="t">
+          <a:bodyPr lIns="0" tIns="0" rIns="0" bIns="0" anchor="t">
             <a:normAutofit/>
           </a:bodyPr>
+          <a:lstStyle/>
           <a:p>
             <a:pPr marL="432000" indent="-324000">
               <a:spcBef>
@@ -1505,7 +1798,7 @@
               <a:buChar char=""/>
             </a:pPr>
             <a:r>
-              <a:rPr b="0" lang="en-US" sz="2400" spc="-1" strike="noStrike">
+              <a:rPr lang="en-US" sz="2400" b="0" strike="noStrike" spc="-1" dirty="0">
                 <a:solidFill>
                   <a:srgbClr val="000000"/>
                 </a:solidFill>
@@ -1513,15 +1806,9 @@
               </a:rPr>
               <a:t>Design-Time component</a:t>
             </a:r>
-            <a:endParaRPr b="0" lang="en-US" sz="2400" spc="-1" strike="noStrike">
-              <a:solidFill>
-                <a:srgbClr val="000000"/>
-              </a:solidFill>
-              <a:latin typeface="Arial"/>
-            </a:endParaRPr>
-          </a:p>
-          <a:p>
-            <a:pPr lvl="1" marL="864000" indent="-324000">
+          </a:p>
+          <a:p>
+            <a:pPr marL="864000" lvl="1" indent="-324000">
               <a:spcBef>
                 <a:spcPts val="1134"/>
               </a:spcBef>
@@ -1533,29 +1820,14 @@
               <a:buChar char=""/>
             </a:pPr>
             <a:r>
-              <a:rPr b="0" lang="en-US" sz="2400" spc="-1" strike="noStrike">
-                <a:solidFill>
-                  <a:srgbClr val="000000"/>
-                </a:solidFill>
-                <a:latin typeface="Arial"/>
-              </a:rPr>
-              <a:t>Look-Up table for a fixed component order, and partition </a:t>
-            </a:r>
-            <a:r>
-              <a:rPr b="0" lang="en-US" sz="2400" spc="-1" strike="noStrike">
-                <a:solidFill>
-                  <a:srgbClr val="000000"/>
-                </a:solidFill>
-                <a:latin typeface="Arial"/>
-              </a:rPr>
-              <a:t>points.</a:t>
-            </a:r>
-            <a:endParaRPr b="0" lang="en-US" sz="2400" spc="-1" strike="noStrike">
-              <a:solidFill>
-                <a:srgbClr val="000000"/>
-              </a:solidFill>
-              <a:latin typeface="Arial"/>
-            </a:endParaRPr>
+              <a:rPr lang="en-US" sz="2400" b="0" strike="noStrike" spc="-1" dirty="0">
+                <a:solidFill>
+                  <a:srgbClr val="000000"/>
+                </a:solidFill>
+                <a:latin typeface="Arial"/>
+              </a:rPr>
+              <a:t>Look-Up table for a fixed component order, and partition points.</a:t>
+            </a:r>
           </a:p>
           <a:p>
             <a:pPr marL="432000" indent="-324000">
@@ -1570,7 +1842,7 @@
               <a:buChar char=""/>
             </a:pPr>
             <a:r>
-              <a:rPr b="0" lang="en-US" sz="2400" spc="-1" strike="noStrike">
+              <a:rPr lang="en-US" sz="2400" b="0" strike="noStrike" spc="-1" dirty="0">
                 <a:solidFill>
                   <a:srgbClr val="000000"/>
                 </a:solidFill>
@@ -1578,15 +1850,9 @@
               </a:rPr>
               <a:t>Run-Time component</a:t>
             </a:r>
-            <a:endParaRPr b="0" lang="en-US" sz="2400" spc="-1" strike="noStrike">
-              <a:solidFill>
-                <a:srgbClr val="000000"/>
-              </a:solidFill>
-              <a:latin typeface="Arial"/>
-            </a:endParaRPr>
-          </a:p>
-          <a:p>
-            <a:pPr lvl="1" marL="864000" indent="-324000">
+          </a:p>
+          <a:p>
+            <a:pPr marL="864000" lvl="1" indent="-324000">
               <a:spcBef>
                 <a:spcPts val="1134"/>
               </a:spcBef>
@@ -1598,7 +1864,7 @@
               <a:buChar char=""/>
             </a:pPr>
             <a:r>
-              <a:rPr b="0" lang="en-US" sz="2400" spc="-1" strike="noStrike">
+              <a:rPr lang="en-US" sz="2400" b="0" strike="noStrike" spc="-1" dirty="0">
                 <a:solidFill>
                   <a:srgbClr val="000000"/>
                 </a:solidFill>
@@ -1606,15 +1872,9 @@
               </a:rPr>
               <a:t>MIMO PID controllers</a:t>
             </a:r>
-            <a:endParaRPr b="0" lang="en-US" sz="2400" spc="-1" strike="noStrike">
-              <a:solidFill>
-                <a:srgbClr val="000000"/>
-              </a:solidFill>
-              <a:latin typeface="Arial"/>
-            </a:endParaRPr>
-          </a:p>
-          <a:p>
-            <a:pPr lvl="2" marL="1296000" indent="-288000">
+          </a:p>
+          <a:p>
+            <a:pPr marL="1296000" lvl="2" indent="-288000">
               <a:spcBef>
                 <a:spcPts val="850"/>
               </a:spcBef>
@@ -1626,7 +1886,7 @@
               <a:buChar char=""/>
             </a:pPr>
             <a:r>
-              <a:rPr b="0" lang="en-US" sz="2400" spc="-1" strike="noStrike">
+              <a:rPr lang="en-US" sz="2400" b="0" strike="noStrike" spc="-1" dirty="0">
                 <a:solidFill>
                   <a:srgbClr val="000000"/>
                 </a:solidFill>
@@ -1634,15 +1894,9 @@
               </a:rPr>
               <a:t>DVFS</a:t>
             </a:r>
-            <a:endParaRPr b="0" lang="en-US" sz="2400" spc="-1" strike="noStrike">
-              <a:solidFill>
-                <a:srgbClr val="000000"/>
-              </a:solidFill>
-              <a:latin typeface="Arial"/>
-            </a:endParaRPr>
-          </a:p>
-          <a:p>
-            <a:pPr lvl="2" marL="1296000" indent="-288000">
+          </a:p>
+          <a:p>
+            <a:pPr marL="1296000" lvl="2" indent="-288000">
               <a:spcBef>
                 <a:spcPts val="850"/>
               </a:spcBef>
@@ -1654,7 +1908,7 @@
               <a:buChar char=""/>
             </a:pPr>
             <a:r>
-              <a:rPr b="0" lang="en-US" sz="2400" spc="-1" strike="noStrike">
+              <a:rPr lang="en-US" sz="2400" b="0" strike="noStrike" spc="-1" dirty="0">
                 <a:solidFill>
                   <a:srgbClr val="000000"/>
                 </a:solidFill>
@@ -1662,30 +1916,19 @@
               </a:rPr>
               <a:t>Partition points</a:t>
             </a:r>
-            <a:endParaRPr b="0" lang="en-US" sz="2400" spc="-1" strike="noStrike">
-              <a:solidFill>
-                <a:srgbClr val="000000"/>
-              </a:solidFill>
-              <a:latin typeface="Arial"/>
-            </a:endParaRPr>
           </a:p>
         </p:txBody>
       </p:sp>
     </p:spTree>
   </p:cSld>
-  <mc:AlternateContent>
-    <mc:Choice Requires="p14">
-      <p:transition spd="slow" p14:dur="2000"/>
-    </mc:Choice>
-    <mc:Fallback>
-      <p:transition spd="slow"/>
-    </mc:Fallback>
-  </mc:AlternateContent>
+  <p:clrMapOvr>
+    <a:masterClrMapping/>
+  </p:clrMapOvr>
 </p:sld>
 </file>
 
 <file path=ppt/slides/slide4.xml><?xml version="1.0" encoding="utf-8"?>
-<p:sld xmlns:a="http://schemas.openxmlformats.org/drawingml/2006/main" xmlns:p="http://schemas.openxmlformats.org/presentationml/2006/main" xmlns:r="http://schemas.openxmlformats.org/officeDocument/2006/relationships" xmlns:p14="http://schemas.microsoft.com/office/powerpoint/2010/main" xmlns:p15="http://schemas.microsoft.com/office/powerpoint/2012/main" xmlns:mc="http://schemas.openxmlformats.org/markup-compatibility/2006">
+<p:sld xmlns:a="http://schemas.openxmlformats.org/drawingml/2006/main" xmlns:r="http://schemas.openxmlformats.org/officeDocument/2006/relationships" xmlns:p="http://schemas.openxmlformats.org/presentationml/2006/main">
   <p:cSld>
     <p:spTree>
       <p:nvGrpSpPr>
@@ -1725,15 +1968,16 @@
           </a:ln>
         </p:spPr>
         <p:txBody>
-          <a:bodyPr lIns="0" rIns="0" tIns="0" bIns="0" anchor="ctr">
+          <a:bodyPr lIns="0" tIns="0" rIns="0" bIns="0" anchor="ctr">
             <a:noAutofit/>
           </a:bodyPr>
+          <a:lstStyle/>
           <a:p>
             <a:pPr indent="0" algn="ctr">
               <a:buNone/>
             </a:pPr>
             <a:r>
-              <a:rPr b="0" lang="en-US" sz="4400" spc="-1" strike="noStrike">
+              <a:rPr lang="en-US" sz="4400" b="0" strike="noStrike" spc="-1">
                 <a:solidFill>
                   <a:srgbClr val="000000"/>
                 </a:solidFill>
@@ -1741,12 +1985,6 @@
               </a:rPr>
               <a:t>Design-Time: Look-Up table</a:t>
             </a:r>
-            <a:endParaRPr b="0" lang="en-US" sz="4400" spc="-1" strike="noStrike">
-              <a:solidFill>
-                <a:srgbClr val="000000"/>
-              </a:solidFill>
-              <a:latin typeface="Arial"/>
-            </a:endParaRPr>
           </a:p>
         </p:txBody>
       </p:sp>
@@ -1774,9 +2012,10 @@
           </a:ln>
         </p:spPr>
         <p:txBody>
-          <a:bodyPr lIns="0" rIns="0" tIns="0" bIns="0" anchor="t">
+          <a:bodyPr lIns="0" tIns="0" rIns="0" bIns="0" anchor="t">
             <a:normAutofit/>
           </a:bodyPr>
+          <a:lstStyle/>
           <a:p>
             <a:pPr marL="432000" indent="-324000">
               <a:spcBef>
@@ -1790,7 +2029,7 @@
               <a:buChar char=""/>
             </a:pPr>
             <a:r>
-              <a:rPr b="0" lang="en-US" sz="2400" spc="-1" strike="noStrike">
+              <a:rPr lang="en-US" sz="2400" b="0" strike="noStrike" spc="-1">
                 <a:solidFill>
                   <a:srgbClr val="000000"/>
                 </a:solidFill>
@@ -1799,7 +2038,7 @@
               <a:t>Matrix that contains all (TP, Latency) pairs of a </a:t>
             </a:r>
             <a:r>
-              <a:rPr b="1" lang="en-US" sz="2400" spc="-1" strike="noStrike">
+              <a:rPr lang="en-US" sz="2400" b="1" strike="noStrike" spc="-1">
                 <a:solidFill>
                   <a:srgbClr val="000000"/>
                 </a:solidFill>
@@ -1808,7 +2047,7 @@
               <a:t>G-B-L, 4-6 </a:t>
             </a:r>
             <a:r>
-              <a:rPr b="0" lang="en-US" sz="2400" spc="-1" strike="noStrike">
+              <a:rPr lang="en-US" sz="2400" b="0" strike="noStrike" spc="-1">
                 <a:solidFill>
                   <a:srgbClr val="000000"/>
                 </a:solidFill>
@@ -1816,12 +2055,6 @@
               </a:rPr>
               <a:t>pipeline.</a:t>
             </a:r>
-            <a:endParaRPr b="0" lang="en-US" sz="2400" spc="-1" strike="noStrike">
-              <a:solidFill>
-                <a:srgbClr val="000000"/>
-              </a:solidFill>
-              <a:latin typeface="Arial"/>
-            </a:endParaRPr>
           </a:p>
           <a:p>
             <a:pPr marL="432000" indent="-324000">
@@ -1836,7 +2069,7 @@
               <a:buChar char=""/>
             </a:pPr>
             <a:r>
-              <a:rPr b="0" lang="en-US" sz="2400" spc="-1" strike="noStrike">
+              <a:rPr lang="en-US" sz="2400" b="0" strike="noStrike" spc="-1">
                 <a:solidFill>
                   <a:srgbClr val="000000"/>
                 </a:solidFill>
@@ -1844,12 +2077,6 @@
               </a:rPr>
               <a:t>All entries compared against target TP and Latency → choose configuration with lowest error.</a:t>
             </a:r>
-            <a:endParaRPr b="0" lang="en-US" sz="2400" spc="-1" strike="noStrike">
-              <a:solidFill>
-                <a:srgbClr val="000000"/>
-              </a:solidFill>
-              <a:latin typeface="Arial"/>
-            </a:endParaRPr>
           </a:p>
           <a:p>
             <a:pPr marL="432000" indent="-324000">
@@ -1864,7 +2091,7 @@
               <a:buChar char=""/>
             </a:pPr>
             <a:r>
-              <a:rPr b="0" lang="en-US" sz="2400" spc="-1" strike="noStrike">
+              <a:rPr lang="en-US" sz="2400" b="0" strike="noStrike" spc="-1">
                 <a:solidFill>
                   <a:srgbClr val="000000"/>
                 </a:solidFill>
@@ -1872,30 +2099,19 @@
               </a:rPr>
               <a:t>Assumption: given that this is overall an efficient pipeline, the optimal solution will be close to this solution. </a:t>
             </a:r>
-            <a:endParaRPr b="0" lang="en-US" sz="2400" spc="-1" strike="noStrike">
-              <a:solidFill>
-                <a:srgbClr val="000000"/>
-              </a:solidFill>
-              <a:latin typeface="Arial"/>
-            </a:endParaRPr>
           </a:p>
         </p:txBody>
       </p:sp>
     </p:spTree>
   </p:cSld>
-  <mc:AlternateContent>
-    <mc:Choice Requires="p14">
-      <p:transition spd="slow" p14:dur="2000"/>
-    </mc:Choice>
-    <mc:Fallback>
-      <p:transition spd="slow"/>
-    </mc:Fallback>
-  </mc:AlternateContent>
+  <p:clrMapOvr>
+    <a:masterClrMapping/>
+  </p:clrMapOvr>
 </p:sld>
 </file>
 
 <file path=ppt/slides/slide5.xml><?xml version="1.0" encoding="utf-8"?>
-<p:sld xmlns:a="http://schemas.openxmlformats.org/drawingml/2006/main" xmlns:p="http://schemas.openxmlformats.org/presentationml/2006/main" xmlns:r="http://schemas.openxmlformats.org/officeDocument/2006/relationships" xmlns:p14="http://schemas.microsoft.com/office/powerpoint/2010/main" xmlns:p15="http://schemas.microsoft.com/office/powerpoint/2012/main" xmlns:mc="http://schemas.openxmlformats.org/markup-compatibility/2006">
+<p:sld xmlns:a="http://schemas.openxmlformats.org/drawingml/2006/main" xmlns:r="http://schemas.openxmlformats.org/officeDocument/2006/relationships" xmlns:p="http://schemas.openxmlformats.org/presentationml/2006/main">
   <p:cSld>
     <p:spTree>
       <p:nvGrpSpPr>
@@ -1935,15 +2151,16 @@
           </a:ln>
         </p:spPr>
         <p:txBody>
-          <a:bodyPr lIns="0" rIns="0" tIns="0" bIns="0" anchor="ctr">
+          <a:bodyPr lIns="0" tIns="0" rIns="0" bIns="0" anchor="ctr">
             <a:noAutofit/>
           </a:bodyPr>
+          <a:lstStyle/>
           <a:p>
             <a:pPr indent="0" algn="ctr">
               <a:buNone/>
             </a:pPr>
             <a:r>
-              <a:rPr b="0" lang="en-US" sz="4400" spc="-1" strike="noStrike">
+              <a:rPr lang="en-US" sz="4400" b="0" strike="noStrike" spc="-1">
                 <a:solidFill>
                   <a:srgbClr val="000000"/>
                 </a:solidFill>
@@ -1951,12 +2168,6 @@
               </a:rPr>
               <a:t>Run-Time: MIMO PID-Controller</a:t>
             </a:r>
-            <a:endParaRPr b="0" lang="en-US" sz="4400" spc="-1" strike="noStrike">
-              <a:solidFill>
-                <a:srgbClr val="000000"/>
-              </a:solidFill>
-              <a:latin typeface="Arial"/>
-            </a:endParaRPr>
           </a:p>
         </p:txBody>
       </p:sp>
@@ -1984,9 +2195,10 @@
           </a:ln>
         </p:spPr>
         <p:txBody>
-          <a:bodyPr lIns="0" rIns="0" tIns="0" bIns="0" anchor="t">
-            <a:normAutofit/>
+          <a:bodyPr lIns="0" tIns="0" rIns="0" bIns="0" anchor="t">
+            <a:normAutofit lnSpcReduction="10000"/>
           </a:bodyPr>
+          <a:lstStyle/>
           <a:p>
             <a:pPr marL="432000" indent="-324000">
               <a:spcBef>
@@ -2000,7 +2212,7 @@
               <a:buChar char=""/>
             </a:pPr>
             <a:r>
-              <a:rPr b="0" lang="en-US" sz="2400" spc="-1" strike="noStrike">
+              <a:rPr lang="en-US" sz="2400" b="0" strike="noStrike" spc="-1" dirty="0">
                 <a:solidFill>
                   <a:srgbClr val="000000"/>
                 </a:solidFill>
@@ -2008,15 +2220,9 @@
               </a:rPr>
               <a:t>MIMO PID → 2 nested PIDs</a:t>
             </a:r>
-            <a:endParaRPr b="0" lang="en-US" sz="2400" spc="-1" strike="noStrike">
-              <a:solidFill>
-                <a:srgbClr val="000000"/>
-              </a:solidFill>
-              <a:latin typeface="Arial"/>
-            </a:endParaRPr>
-          </a:p>
-          <a:p>
-            <a:pPr lvl="1" marL="864000" indent="-324000">
+          </a:p>
+          <a:p>
+            <a:pPr marL="864000" lvl="1" indent="-324000">
               <a:spcBef>
                 <a:spcPts val="1134"/>
               </a:spcBef>
@@ -2028,7 +2234,7 @@
               <a:buChar char=""/>
             </a:pPr>
             <a:r>
-              <a:rPr b="0" lang="en-US" sz="2400" spc="-1" strike="noStrike">
+              <a:rPr lang="en-US" sz="2400" b="0" strike="noStrike" spc="-1" dirty="0">
                 <a:solidFill>
                   <a:srgbClr val="000000"/>
                 </a:solidFill>
@@ -2036,15 +2242,9 @@
               </a:rPr>
               <a:t>Partition points → Latency, TP</a:t>
             </a:r>
-            <a:endParaRPr b="0" lang="en-US" sz="2400" spc="-1" strike="noStrike">
-              <a:solidFill>
-                <a:srgbClr val="000000"/>
-              </a:solidFill>
-              <a:latin typeface="Arial"/>
-            </a:endParaRPr>
-          </a:p>
-          <a:p>
-            <a:pPr lvl="1" marL="864000" indent="-324000">
+          </a:p>
+          <a:p>
+            <a:pPr marL="864000" lvl="1" indent="-324000">
               <a:spcBef>
                 <a:spcPts val="1134"/>
               </a:spcBef>
@@ -2056,7 +2256,7 @@
               <a:buChar char=""/>
             </a:pPr>
             <a:r>
-              <a:rPr b="0" lang="en-US" sz="2400" spc="-1" strike="noStrike">
+              <a:rPr lang="en-US" sz="2400" b="0" strike="noStrike" spc="-1" dirty="0">
                 <a:solidFill>
                   <a:srgbClr val="000000"/>
                 </a:solidFill>
@@ -2064,12 +2264,6 @@
               </a:rPr>
               <a:t>DVFS → Latency, TP</a:t>
             </a:r>
-            <a:endParaRPr b="0" lang="en-US" sz="2400" spc="-1" strike="noStrike">
-              <a:solidFill>
-                <a:srgbClr val="000000"/>
-              </a:solidFill>
-              <a:latin typeface="Arial"/>
-            </a:endParaRPr>
           </a:p>
           <a:p>
             <a:pPr marL="432000" indent="-324000">
@@ -2087,7 +2281,7 @@
               <a:buChar char=""/>
             </a:pPr>
             <a:r>
-              <a:rPr b="0" lang="en-US" sz="2400" spc="-1" strike="noStrike">
+              <a:rPr lang="en-US" sz="2400" b="0" strike="noStrike" spc="-1" dirty="0">
                 <a:solidFill>
                   <a:srgbClr val="000000"/>
                 </a:solidFill>
@@ -2096,7 +2290,7 @@
               <a:t>constrained optimization problem: </a:t>
             </a:r>
             <a:r>
-              <a:rPr b="1" lang="en-US" sz="2400" spc="-1" strike="noStrike">
+              <a:rPr lang="en-US" sz="2400" b="1" strike="noStrike" spc="-1" dirty="0">
                 <a:solidFill>
                   <a:srgbClr val="000000"/>
                 </a:solidFill>
@@ -2105,7 +2299,7 @@
               <a:t>minimize power consumption</a:t>
             </a:r>
             <a:r>
-              <a:rPr b="0" lang="en-US" sz="2400" spc="-1" strike="noStrike">
+              <a:rPr lang="en-US" sz="2400" b="0" strike="noStrike" spc="-1" dirty="0">
                 <a:solidFill>
                   <a:srgbClr val="000000"/>
                 </a:solidFill>
@@ -2114,7 +2308,7 @@
               <a:t> while </a:t>
             </a:r>
             <a:r>
-              <a:rPr b="1" lang="en-US" sz="2400" spc="-1" strike="noStrike">
+              <a:rPr lang="en-US" sz="2400" b="1" strike="noStrike" spc="-1" dirty="0">
                 <a:solidFill>
                   <a:srgbClr val="000000"/>
                 </a:solidFill>
@@ -2122,7 +2316,7 @@
               </a:rPr>
               <a:t>meeting TP and latency targets</a:t>
             </a:r>
-            <a:endParaRPr b="0" lang="en-US" sz="2400" spc="-1" strike="noStrike">
+            <a:endParaRPr lang="en-US" sz="2400" b="0" strike="noStrike" spc="-1" dirty="0">
               <a:solidFill>
                 <a:srgbClr val="000000"/>
               </a:solidFill>
@@ -2145,7 +2339,7 @@
               <a:buChar char=""/>
             </a:pPr>
             <a:r>
-              <a:rPr b="1" lang="en-US" sz="2400" spc="-1" strike="noStrike">
+              <a:rPr lang="en-US" sz="2400" b="1" strike="noStrike" spc="-1" dirty="0">
                 <a:solidFill>
                   <a:srgbClr val="000000"/>
                 </a:solidFill>
@@ -2154,7 +2348,7 @@
               <a:t>Model-free </a:t>
             </a:r>
             <a:r>
-              <a:rPr b="0" lang="en-US" sz="2400" spc="-1" strike="noStrike">
+              <a:rPr lang="en-US" sz="2400" b="0" strike="noStrike" spc="-1" dirty="0">
                 <a:solidFill>
                   <a:srgbClr val="000000"/>
                 </a:solidFill>
@@ -2162,12 +2356,6 @@
               </a:rPr>
               <a:t>variation: because few data → bad model</a:t>
             </a:r>
-            <a:endParaRPr b="0" lang="en-US" sz="2400" spc="-1" strike="noStrike">
-              <a:solidFill>
-                <a:srgbClr val="000000"/>
-              </a:solidFill>
-              <a:latin typeface="Arial"/>
-            </a:endParaRPr>
           </a:p>
           <a:p>
             <a:pPr marL="432000" indent="-324000">
@@ -2185,7 +2373,7 @@
               <a:buChar char=""/>
             </a:pPr>
             <a:r>
-              <a:rPr b="0" lang="en-US" sz="2400" spc="-1" strike="noStrike">
+              <a:rPr lang="en-US" sz="2400" b="0" strike="noStrike" spc="-1" dirty="0">
                 <a:solidFill>
                   <a:srgbClr val="000000"/>
                 </a:solidFill>
@@ -2193,30 +2381,19 @@
               </a:rPr>
               <a:t>Heavily relies on power estimation model</a:t>
             </a:r>
-            <a:endParaRPr b="0" lang="en-US" sz="2400" spc="-1" strike="noStrike">
-              <a:solidFill>
-                <a:srgbClr val="000000"/>
-              </a:solidFill>
-              <a:latin typeface="Arial"/>
-            </a:endParaRPr>
           </a:p>
         </p:txBody>
       </p:sp>
     </p:spTree>
   </p:cSld>
-  <mc:AlternateContent>
-    <mc:Choice Requires="p14">
-      <p:transition spd="slow" p14:dur="2000"/>
-    </mc:Choice>
-    <mc:Fallback>
-      <p:transition spd="slow"/>
-    </mc:Fallback>
-  </mc:AlternateContent>
+  <p:clrMapOvr>
+    <a:masterClrMapping/>
+  </p:clrMapOvr>
 </p:sld>
 </file>
 
 <file path=ppt/slides/slide6.xml><?xml version="1.0" encoding="utf-8"?>
-<p:sld xmlns:a="http://schemas.openxmlformats.org/drawingml/2006/main" xmlns:p="http://schemas.openxmlformats.org/presentationml/2006/main" xmlns:r="http://schemas.openxmlformats.org/officeDocument/2006/relationships" xmlns:p14="http://schemas.microsoft.com/office/powerpoint/2010/main" xmlns:p15="http://schemas.microsoft.com/office/powerpoint/2012/main" xmlns:mc="http://schemas.openxmlformats.org/markup-compatibility/2006">
+<p:sld xmlns:a="http://schemas.openxmlformats.org/drawingml/2006/main" xmlns:r="http://schemas.openxmlformats.org/officeDocument/2006/relationships" xmlns:p="http://schemas.openxmlformats.org/presentationml/2006/main">
   <p:cSld>
     <p:spTree>
       <p:nvGrpSpPr>
@@ -2256,15 +2433,16 @@
           </a:ln>
         </p:spPr>
         <p:txBody>
-          <a:bodyPr lIns="0" rIns="0" tIns="0" bIns="0" anchor="ctr">
+          <a:bodyPr lIns="0" tIns="0" rIns="0" bIns="0" anchor="ctr">
             <a:noAutofit/>
           </a:bodyPr>
+          <a:lstStyle/>
           <a:p>
             <a:pPr indent="0" algn="ctr">
               <a:buNone/>
             </a:pPr>
             <a:r>
-              <a:rPr b="0" lang="en-US" sz="4400" spc="-1" strike="noStrike">
+              <a:rPr lang="en-US" sz="4400" b="0" strike="noStrike" spc="-1">
                 <a:solidFill>
                   <a:srgbClr val="000000"/>
                 </a:solidFill>
@@ -2272,12 +2450,6 @@
               </a:rPr>
               <a:t>PID Controller</a:t>
             </a:r>
-            <a:endParaRPr b="0" lang="en-US" sz="4400" spc="-1" strike="noStrike">
-              <a:solidFill>
-                <a:srgbClr val="000000"/>
-              </a:solidFill>
-              <a:latin typeface="Arial"/>
-            </a:endParaRPr>
           </a:p>
         </p:txBody>
       </p:sp>
@@ -2305,9 +2477,10 @@
           </a:ln>
         </p:spPr>
         <p:txBody>
-          <a:bodyPr lIns="0" rIns="0" tIns="0" bIns="0" anchor="t">
+          <a:bodyPr lIns="0" tIns="0" rIns="0" bIns="0" anchor="t">
             <a:normAutofit/>
           </a:bodyPr>
+          <a:lstStyle/>
           <a:p>
             <a:pPr indent="0">
               <a:spcBef>
@@ -2315,7 +2488,7 @@
               </a:spcBef>
               <a:buNone/>
             </a:pPr>
-            <a:endParaRPr b="0" lang="en-US" sz="3200" spc="-1" strike="noStrike">
+            <a:endParaRPr lang="en-US" sz="3200" b="0" strike="noStrike" spc="-1">
               <a:solidFill>
                 <a:srgbClr val="000000"/>
               </a:solidFill>
@@ -2326,12 +2499,12 @@
       </p:sp>
       <p:pic>
         <p:nvPicPr>
-          <p:cNvPr id="23" name="" descr=""/>
+          <p:cNvPr id="23" name="Picture 22"/>
           <p:cNvPicPr/>
           <p:nvPr/>
         </p:nvPicPr>
         <p:blipFill>
-          <a:blip r:embed="rId1"/>
+          <a:blip r:embed="rId2"/>
           <a:stretch/>
         </p:blipFill>
         <p:spPr>
@@ -2349,19 +2522,14 @@
       </p:pic>
     </p:spTree>
   </p:cSld>
-  <mc:AlternateContent>
-    <mc:Choice Requires="p14">
-      <p:transition spd="slow" p14:dur="2000"/>
-    </mc:Choice>
-    <mc:Fallback>
-      <p:transition spd="slow"/>
-    </mc:Fallback>
-  </mc:AlternateContent>
+  <p:clrMapOvr>
+    <a:masterClrMapping/>
+  </p:clrMapOvr>
 </p:sld>
 </file>
 
 <file path=ppt/slides/slide7.xml><?xml version="1.0" encoding="utf-8"?>
-<p:sld xmlns:a="http://schemas.openxmlformats.org/drawingml/2006/main" xmlns:p="http://schemas.openxmlformats.org/presentationml/2006/main" xmlns:r="http://schemas.openxmlformats.org/officeDocument/2006/relationships" xmlns:p14="http://schemas.microsoft.com/office/powerpoint/2010/main" xmlns:p15="http://schemas.microsoft.com/office/powerpoint/2012/main" xmlns:mc="http://schemas.openxmlformats.org/markup-compatibility/2006">
+<p:sld xmlns:a="http://schemas.openxmlformats.org/drawingml/2006/main" xmlns:r="http://schemas.openxmlformats.org/officeDocument/2006/relationships" xmlns:p="http://schemas.openxmlformats.org/presentationml/2006/main">
   <p:cSld>
     <p:spTree>
       <p:nvGrpSpPr>
@@ -2389,7 +2557,7 @@
         </p:nvSpPr>
         <p:spPr>
           <a:xfrm>
-            <a:off x="504000" y="226080"/>
+            <a:off x="412560" y="0"/>
             <a:ext cx="9071640" cy="946440"/>
           </a:xfrm>
           <a:prstGeom prst="rect">
@@ -2401,15 +2569,16 @@
           </a:ln>
         </p:spPr>
         <p:txBody>
-          <a:bodyPr lIns="0" rIns="0" tIns="0" bIns="0" anchor="ctr">
+          <a:bodyPr lIns="0" tIns="0" rIns="0" bIns="0" anchor="ctr">
             <a:noAutofit/>
           </a:bodyPr>
+          <a:lstStyle/>
           <a:p>
             <a:pPr indent="0" algn="ctr">
               <a:buNone/>
             </a:pPr>
             <a:r>
-              <a:rPr b="0" lang="en-US" sz="4400" spc="-1" strike="noStrike">
+              <a:rPr lang="en-US" sz="4400" b="0" strike="noStrike" spc="-1" dirty="0">
                 <a:solidFill>
                   <a:srgbClr val="000000"/>
                 </a:solidFill>
@@ -2417,73 +2586,1302 @@
               </a:rPr>
               <a:t>PID Decisions</a:t>
             </a:r>
-            <a:endParaRPr b="0" lang="en-US" sz="4400" spc="-1" strike="noStrike">
-              <a:solidFill>
-                <a:srgbClr val="000000"/>
-              </a:solidFill>
-              <a:latin typeface="Arial"/>
-            </a:endParaRPr>
           </a:p>
         </p:txBody>
       </p:sp>
       <p:sp>
         <p:nvSpPr>
-          <p:cNvPr id="25" name="PlaceHolder 2"/>
+          <p:cNvPr id="3" name="Content Placeholder 2">
+            <a:extLst>
+              <a:ext uri="{FF2B5EF4-FFF2-40B4-BE49-F238E27FC236}">
+                <a16:creationId xmlns:a16="http://schemas.microsoft.com/office/drawing/2014/main" id="{1B36280C-CA59-9431-AE44-ADEEA4A18FCA}"/>
+              </a:ext>
+            </a:extLst>
+          </p:cNvPr>
           <p:cNvSpPr>
-            <a:spLocks noGrp="1"/>
+            <a:spLocks noGrp="1" noChangeArrowheads="1"/>
           </p:cNvSpPr>
           <p:nvPr>
             <p:ph/>
           </p:nvPr>
         </p:nvSpPr>
-        <p:spPr>
+        <p:spPr bwMode="auto">
           <a:xfrm>
-            <a:off x="504000" y="1326600"/>
-            <a:ext cx="9071640" cy="3288240"/>
+            <a:off x="495300" y="776903"/>
+            <a:ext cx="8299260" cy="4893647"/>
           </a:xfrm>
           <a:prstGeom prst="rect">
             <a:avLst/>
           </a:prstGeom>
           <a:noFill/>
-          <a:ln w="0">
+          <a:ln>
             <a:noFill/>
           </a:ln>
+          <a:effectLst/>
+          <a:extLst>
+            <a:ext uri="{909E8E84-426E-40DD-AFC4-6F175D3DCCD1}">
+              <a14:hiddenFill xmlns:a14="http://schemas.microsoft.com/office/drawing/2010/main">
+                <a:solidFill>
+                  <a:schemeClr val="accent1"/>
+                </a:solidFill>
+              </a14:hiddenFill>
+            </a:ext>
+            <a:ext uri="{91240B29-F687-4F45-9708-019B960494DF}">
+              <a14:hiddenLine xmlns:a14="http://schemas.microsoft.com/office/drawing/2010/main" w="9525">
+                <a:solidFill>
+                  <a:schemeClr val="tx1"/>
+                </a:solidFill>
+                <a:miter lim="800000"/>
+                <a:headEnd/>
+                <a:tailEnd/>
+              </a14:hiddenLine>
+            </a:ext>
+            <a:ext uri="{AF507438-7753-43E0-B8FC-AC1667EBCBE1}">
+              <a14:hiddenEffects xmlns:a14="http://schemas.microsoft.com/office/drawing/2010/main">
+                <a:effectLst>
+                  <a:outerShdw dist="35921" dir="2700000" algn="ctr" rotWithShape="0">
+                    <a:schemeClr val="bg2"/>
+                  </a:outerShdw>
+                </a:effectLst>
+              </a14:hiddenEffects>
+            </a:ext>
+          </a:extLst>
         </p:spPr>
         <p:txBody>
-          <a:bodyPr lIns="0" rIns="0" tIns="0" bIns="0" anchor="t">
-            <a:normAutofit/>
+          <a:bodyPr vert="horz" wrap="square" lIns="91440" tIns="45720" rIns="91440" bIns="45720" numCol="1" anchor="ctr" anchorCtr="0" compatLnSpc="1">
+            <a:prstTxWarp prst="textNoShape">
+              <a:avLst/>
+            </a:prstTxWarp>
+            <a:spAutoFit/>
           </a:bodyPr>
-          <a:p>
-            <a:pPr indent="0">
-              <a:spcBef>
-                <a:spcPts val="1417"/>
-              </a:spcBef>
+          <a:lstStyle/>
+          <a:p>
+            <a:pPr marL="285750" marR="0" lvl="0" indent="-285750" algn="l" defTabSz="914400" rtl="0" eaLnBrk="0" fontAlgn="base" latinLnBrk="0" hangingPunct="0">
+              <a:lnSpc>
+                <a:spcPct val="100000"/>
+              </a:lnSpc>
+              <a:spcBef>
+                <a:spcPct val="0"/>
+              </a:spcBef>
+              <a:spcAft>
+                <a:spcPct val="0"/>
+              </a:spcAft>
+              <a:buClrTx/>
+              <a:buSzTx/>
+              <a:buFont typeface="Arial" panose="020B0604020202020204" pitchFamily="34" charset="0"/>
+              <a:buChar char="•"/>
+              <a:tabLst/>
+            </a:pPr>
+            <a:r>
+              <a:rPr kumimoji="0" lang="en-SI" altLang="en-SI" sz="1400" b="1" i="0" u="none" strike="noStrike" cap="none" normalizeH="0" baseline="0" dirty="0">
+                <a:ln>
+                  <a:noFill/>
+                </a:ln>
+                <a:solidFill>
+                  <a:schemeClr val="tx1"/>
+                </a:solidFill>
+                <a:effectLst/>
+                <a:latin typeface="Arial" panose="020B0604020202020204" pitchFamily="34" charset="0"/>
+              </a:rPr>
+              <a:t>Inputs per iteration</a:t>
+            </a:r>
+            <a:endParaRPr kumimoji="0" lang="en-SI" altLang="en-SI" sz="1400" b="0" i="0" u="none" strike="noStrike" cap="none" normalizeH="0" baseline="0" dirty="0">
+              <a:ln>
+                <a:noFill/>
+              </a:ln>
+              <a:solidFill>
+                <a:schemeClr val="tx1"/>
+              </a:solidFill>
+              <a:effectLst/>
+              <a:latin typeface="Arial" panose="020B0604020202020204" pitchFamily="34" charset="0"/>
+            </a:endParaRPr>
+          </a:p>
+          <a:p>
+            <a:pPr marL="0" marR="0" lvl="0" indent="0" algn="l" defTabSz="914400" rtl="0" eaLnBrk="0" fontAlgn="base" latinLnBrk="0" hangingPunct="0">
+              <a:lnSpc>
+                <a:spcPct val="100000"/>
+              </a:lnSpc>
+              <a:spcBef>
+                <a:spcPct val="0"/>
+              </a:spcBef>
+              <a:spcAft>
+                <a:spcPct val="0"/>
+              </a:spcAft>
+              <a:buClrTx/>
+              <a:buSzTx/>
+              <a:tabLst/>
+            </a:pPr>
+            <a:r>
+              <a:rPr lang="en-US" altLang="en-SI" sz="1400" dirty="0">
+                <a:latin typeface="Arial" panose="020B0604020202020204" pitchFamily="34" charset="0"/>
+              </a:rPr>
+              <a:t>	- </a:t>
+            </a:r>
+            <a:r>
+              <a:rPr kumimoji="0" lang="en-SI" altLang="en-SI" sz="1400" b="0" i="0" u="none" strike="noStrike" cap="none" normalizeH="0" baseline="0" dirty="0">
+                <a:ln>
+                  <a:noFill/>
+                </a:ln>
+                <a:solidFill>
+                  <a:schemeClr val="tx1"/>
+                </a:solidFill>
+                <a:effectLst/>
+                <a:latin typeface="Arial" panose="020B0604020202020204" pitchFamily="34" charset="0"/>
+              </a:rPr>
+              <a:t>Targets: </a:t>
+            </a:r>
+            <a:r>
+              <a:rPr kumimoji="0" lang="en-SI" altLang="en-SI" sz="1400" b="0" i="0" u="none" strike="noStrike" cap="none" normalizeH="0" baseline="0" dirty="0" err="1">
+                <a:ln>
+                  <a:noFill/>
+                </a:ln>
+                <a:solidFill>
+                  <a:schemeClr val="tx1"/>
+                </a:solidFill>
+                <a:effectLst/>
+                <a:latin typeface="Arial Unicode MS"/>
+              </a:rPr>
+              <a:t>target_fps</a:t>
+            </a:r>
+            <a:r>
+              <a:rPr kumimoji="0" lang="en-SI" altLang="en-SI" sz="1400" b="0" i="0" u="none" strike="noStrike" cap="none" normalizeH="0" baseline="0" dirty="0">
+                <a:ln>
+                  <a:noFill/>
+                </a:ln>
+                <a:solidFill>
+                  <a:schemeClr val="tx1"/>
+                </a:solidFill>
+                <a:effectLst/>
+              </a:rPr>
+              <a:t>, </a:t>
+            </a:r>
+            <a:r>
+              <a:rPr kumimoji="0" lang="en-SI" altLang="en-SI" sz="1400" b="0" i="0" u="none" strike="noStrike" cap="none" normalizeH="0" baseline="0" dirty="0" err="1">
+                <a:ln>
+                  <a:noFill/>
+                </a:ln>
+                <a:solidFill>
+                  <a:schemeClr val="tx1"/>
+                </a:solidFill>
+                <a:effectLst/>
+                <a:latin typeface="Arial Unicode MS"/>
+              </a:rPr>
+              <a:t>target_latency</a:t>
+            </a:r>
+            <a:endParaRPr kumimoji="0" lang="en-SI" altLang="en-SI" sz="1400" b="0" i="0" u="none" strike="noStrike" cap="none" normalizeH="0" baseline="0" dirty="0">
+              <a:ln>
+                <a:noFill/>
+              </a:ln>
+              <a:solidFill>
+                <a:schemeClr val="tx1"/>
+              </a:solidFill>
+              <a:effectLst/>
+            </a:endParaRPr>
+          </a:p>
+          <a:p>
+            <a:pPr marL="0" marR="0" lvl="0" indent="0" algn="l" defTabSz="914400" rtl="0" eaLnBrk="0" fontAlgn="base" latinLnBrk="0" hangingPunct="0">
+              <a:lnSpc>
+                <a:spcPct val="100000"/>
+              </a:lnSpc>
+              <a:spcBef>
+                <a:spcPct val="0"/>
+              </a:spcBef>
+              <a:spcAft>
+                <a:spcPct val="0"/>
+              </a:spcAft>
+              <a:buClrTx/>
+              <a:buSzTx/>
+              <a:tabLst/>
+            </a:pPr>
+            <a:r>
+              <a:rPr kumimoji="0" lang="en-US" altLang="en-SI" sz="1400" b="0" i="0" u="none" strike="noStrike" cap="none" normalizeH="0" baseline="0" dirty="0">
+                <a:ln>
+                  <a:noFill/>
+                </a:ln>
+                <a:solidFill>
+                  <a:schemeClr val="tx1"/>
+                </a:solidFill>
+                <a:effectLst/>
+                <a:latin typeface="Arial" panose="020B0604020202020204" pitchFamily="34" charset="0"/>
+              </a:rPr>
+              <a:t>	- </a:t>
+            </a:r>
+            <a:r>
+              <a:rPr kumimoji="0" lang="en-SI" altLang="en-SI" sz="1400" b="0" i="0" u="none" strike="noStrike" cap="none" normalizeH="0" baseline="0" dirty="0">
+                <a:ln>
+                  <a:noFill/>
+                </a:ln>
+                <a:solidFill>
+                  <a:schemeClr val="tx1"/>
+                </a:solidFill>
+                <a:effectLst/>
+                <a:latin typeface="Arial" panose="020B0604020202020204" pitchFamily="34" charset="0"/>
+              </a:rPr>
+              <a:t>Measurements: </a:t>
+            </a:r>
+            <a:r>
+              <a:rPr kumimoji="0" lang="en-SI" altLang="en-SI" sz="1400" b="0" i="0" u="none" strike="noStrike" cap="none" normalizeH="0" baseline="0" dirty="0">
+                <a:ln>
+                  <a:noFill/>
+                </a:ln>
+                <a:solidFill>
+                  <a:schemeClr val="tx1"/>
+                </a:solidFill>
+                <a:effectLst/>
+                <a:latin typeface="Arial Unicode MS"/>
+              </a:rPr>
+              <a:t>fps</a:t>
+            </a:r>
+            <a:r>
+              <a:rPr kumimoji="0" lang="en-SI" altLang="en-SI" sz="1400" b="0" i="0" u="none" strike="noStrike" cap="none" normalizeH="0" baseline="0" dirty="0">
+                <a:ln>
+                  <a:noFill/>
+                </a:ln>
+                <a:solidFill>
+                  <a:schemeClr val="tx1"/>
+                </a:solidFill>
+                <a:effectLst/>
+              </a:rPr>
+              <a:t>, </a:t>
+            </a:r>
+            <a:r>
+              <a:rPr kumimoji="0" lang="en-SI" altLang="en-SI" sz="1400" b="0" i="0" u="none" strike="noStrike" cap="none" normalizeH="0" baseline="0" dirty="0">
+                <a:ln>
+                  <a:noFill/>
+                </a:ln>
+                <a:solidFill>
+                  <a:schemeClr val="tx1"/>
+                </a:solidFill>
+                <a:effectLst/>
+                <a:latin typeface="Arial Unicode MS"/>
+              </a:rPr>
+              <a:t>latency</a:t>
+            </a:r>
+            <a:r>
+              <a:rPr kumimoji="0" lang="en-SI" altLang="en-SI" sz="1400" b="0" i="0" u="none" strike="noStrike" cap="none" normalizeH="0" baseline="0" dirty="0">
+                <a:ln>
+                  <a:noFill/>
+                </a:ln>
+                <a:solidFill>
+                  <a:schemeClr val="tx1"/>
+                </a:solidFill>
+                <a:effectLst/>
+              </a:rPr>
+              <a:t>, stage times </a:t>
+            </a:r>
+            <a:r>
+              <a:rPr kumimoji="0" lang="en-SI" altLang="en-SI" sz="1400" b="0" i="0" u="none" strike="noStrike" cap="none" normalizeH="0" baseline="0" dirty="0">
+                <a:ln>
+                  <a:noFill/>
+                </a:ln>
+                <a:solidFill>
+                  <a:schemeClr val="tx1"/>
+                </a:solidFill>
+                <a:effectLst/>
+                <a:latin typeface="Arial Unicode MS"/>
+              </a:rPr>
+              <a:t>T1/T2/T3</a:t>
+            </a:r>
+            <a:endParaRPr kumimoji="0" lang="en-US" altLang="en-SI" sz="1400" b="0" i="0" u="none" strike="noStrike" cap="none" normalizeH="0" baseline="0" dirty="0">
+              <a:ln>
+                <a:noFill/>
+              </a:ln>
+              <a:solidFill>
+                <a:schemeClr val="tx1"/>
+              </a:solidFill>
+              <a:effectLst/>
+              <a:latin typeface="Arial Unicode MS"/>
+            </a:endParaRPr>
+          </a:p>
+          <a:p>
+            <a:pPr marL="0" marR="0" lvl="0" indent="0" algn="l" defTabSz="914400" rtl="0" eaLnBrk="0" fontAlgn="base" latinLnBrk="0" hangingPunct="0">
+              <a:lnSpc>
+                <a:spcPct val="100000"/>
+              </a:lnSpc>
+              <a:spcBef>
+                <a:spcPct val="0"/>
+              </a:spcBef>
+              <a:spcAft>
+                <a:spcPct val="0"/>
+              </a:spcAft>
+              <a:buClrTx/>
+              <a:buSzTx/>
+              <a:tabLst/>
+            </a:pPr>
+            <a:endParaRPr kumimoji="0" lang="en-SI" altLang="en-SI" sz="1400" b="0" i="0" u="none" strike="noStrike" cap="none" normalizeH="0" baseline="0" dirty="0">
+              <a:ln>
+                <a:noFill/>
+              </a:ln>
+              <a:solidFill>
+                <a:schemeClr val="tx1"/>
+              </a:solidFill>
+              <a:effectLst/>
+            </a:endParaRPr>
+          </a:p>
+          <a:p>
+            <a:pPr marL="285750" marR="0" lvl="0" indent="-285750" algn="l" defTabSz="914400" rtl="0" eaLnBrk="0" fontAlgn="base" latinLnBrk="0" hangingPunct="0">
+              <a:lnSpc>
+                <a:spcPct val="100000"/>
+              </a:lnSpc>
+              <a:spcBef>
+                <a:spcPct val="0"/>
+              </a:spcBef>
+              <a:spcAft>
+                <a:spcPct val="0"/>
+              </a:spcAft>
+              <a:buClrTx/>
+              <a:buSzTx/>
+              <a:buFont typeface="Arial" panose="020B0604020202020204" pitchFamily="34" charset="0"/>
+              <a:buChar char="•"/>
+              <a:tabLst/>
+            </a:pPr>
+            <a:r>
+              <a:rPr kumimoji="0" lang="en-SI" altLang="en-SI" sz="1400" b="1" i="0" u="none" strike="noStrike" cap="none" normalizeH="0" baseline="0" dirty="0">
+                <a:ln>
+                  <a:noFill/>
+                </a:ln>
+                <a:solidFill>
+                  <a:schemeClr val="tx1"/>
+                </a:solidFill>
+                <a:effectLst/>
+                <a:latin typeface="Arial" panose="020B0604020202020204" pitchFamily="34" charset="0"/>
+              </a:rPr>
+              <a:t>Normalized error signals</a:t>
+            </a:r>
+            <a:endParaRPr kumimoji="0" lang="en-SI" altLang="en-SI" sz="1400" b="0" i="0" u="none" strike="noStrike" cap="none" normalizeH="0" baseline="0" dirty="0">
+              <a:ln>
+                <a:noFill/>
+              </a:ln>
+              <a:solidFill>
+                <a:schemeClr val="tx1"/>
+              </a:solidFill>
+              <a:effectLst/>
+              <a:latin typeface="Arial" panose="020B0604020202020204" pitchFamily="34" charset="0"/>
+            </a:endParaRPr>
+          </a:p>
+          <a:p>
+            <a:pPr marL="0" marR="0" lvl="0" indent="0" algn="l" defTabSz="914400" rtl="0" eaLnBrk="0" fontAlgn="base" latinLnBrk="0" hangingPunct="0">
+              <a:lnSpc>
+                <a:spcPct val="100000"/>
+              </a:lnSpc>
+              <a:spcBef>
+                <a:spcPct val="0"/>
+              </a:spcBef>
+              <a:spcAft>
+                <a:spcPct val="0"/>
+              </a:spcAft>
+              <a:buClrTx/>
+              <a:buSzTx/>
+              <a:tabLst/>
+            </a:pPr>
+            <a:r>
+              <a:rPr kumimoji="0" lang="en-US" altLang="en-SI" sz="1400" b="0" i="0" u="none" strike="noStrike" cap="none" normalizeH="0" baseline="0" dirty="0">
+                <a:ln>
+                  <a:noFill/>
+                </a:ln>
+                <a:solidFill>
+                  <a:schemeClr val="tx1"/>
+                </a:solidFill>
+                <a:effectLst/>
+                <a:latin typeface="Arial Unicode MS"/>
+              </a:rPr>
+              <a:t>	- </a:t>
+            </a:r>
+            <a:r>
+              <a:rPr kumimoji="0" lang="en-SI" altLang="en-SI" sz="1400" b="0" i="0" u="none" strike="noStrike" cap="none" normalizeH="0" baseline="0" dirty="0" err="1">
+                <a:ln>
+                  <a:noFill/>
+                </a:ln>
+                <a:solidFill>
+                  <a:schemeClr val="tx1"/>
+                </a:solidFill>
+                <a:effectLst/>
+                <a:latin typeface="Arial Unicode MS"/>
+              </a:rPr>
+              <a:t>fps_error</a:t>
+            </a:r>
+            <a:r>
+              <a:rPr kumimoji="0" lang="en-SI" altLang="en-SI" sz="1400" b="0" i="0" u="none" strike="noStrike" cap="none" normalizeH="0" baseline="0" dirty="0">
+                <a:ln>
+                  <a:noFill/>
+                </a:ln>
+                <a:solidFill>
+                  <a:schemeClr val="tx1"/>
+                </a:solidFill>
+                <a:effectLst/>
+                <a:latin typeface="Arial Unicode MS"/>
+              </a:rPr>
+              <a:t> = (</a:t>
+            </a:r>
+            <a:r>
+              <a:rPr kumimoji="0" lang="en-SI" altLang="en-SI" sz="1400" b="0" i="0" u="none" strike="noStrike" cap="none" normalizeH="0" baseline="0" dirty="0" err="1">
+                <a:ln>
+                  <a:noFill/>
+                </a:ln>
+                <a:solidFill>
+                  <a:schemeClr val="tx1"/>
+                </a:solidFill>
+                <a:effectLst/>
+                <a:latin typeface="Arial Unicode MS"/>
+              </a:rPr>
+              <a:t>target_fps</a:t>
+            </a:r>
+            <a:r>
+              <a:rPr kumimoji="0" lang="en-SI" altLang="en-SI" sz="1400" b="0" i="0" u="none" strike="noStrike" cap="none" normalizeH="0" baseline="0" dirty="0">
+                <a:ln>
+                  <a:noFill/>
+                </a:ln>
+                <a:solidFill>
+                  <a:schemeClr val="tx1"/>
+                </a:solidFill>
+                <a:effectLst/>
+                <a:latin typeface="Arial Unicode MS"/>
+              </a:rPr>
+              <a:t> − fps) / </a:t>
+            </a:r>
+            <a:r>
+              <a:rPr kumimoji="0" lang="en-SI" altLang="en-SI" sz="1400" b="0" i="0" u="none" strike="noStrike" cap="none" normalizeH="0" baseline="0" dirty="0" err="1">
+                <a:ln>
+                  <a:noFill/>
+                </a:ln>
+                <a:solidFill>
+                  <a:schemeClr val="tx1"/>
+                </a:solidFill>
+                <a:effectLst/>
+                <a:latin typeface="Arial Unicode MS"/>
+              </a:rPr>
+              <a:t>target_fps</a:t>
+            </a:r>
+            <a:endParaRPr kumimoji="0" lang="en-SI" altLang="en-SI" sz="1400" b="0" i="0" u="none" strike="noStrike" cap="none" normalizeH="0" baseline="0" dirty="0">
+              <a:ln>
+                <a:noFill/>
+              </a:ln>
+              <a:solidFill>
+                <a:schemeClr val="tx1"/>
+              </a:solidFill>
+              <a:effectLst/>
+            </a:endParaRPr>
+          </a:p>
+          <a:p>
+            <a:pPr marL="0" marR="0" lvl="0" indent="0" algn="l" defTabSz="914400" rtl="0" eaLnBrk="0" fontAlgn="base" latinLnBrk="0" hangingPunct="0">
+              <a:lnSpc>
+                <a:spcPct val="100000"/>
+              </a:lnSpc>
+              <a:spcBef>
+                <a:spcPct val="0"/>
+              </a:spcBef>
+              <a:spcAft>
+                <a:spcPct val="0"/>
+              </a:spcAft>
+              <a:buClrTx/>
+              <a:buSzTx/>
+              <a:tabLst/>
+            </a:pPr>
+            <a:r>
+              <a:rPr kumimoji="0" lang="en-US" altLang="en-SI" sz="1400" b="0" i="0" u="none" strike="noStrike" cap="none" normalizeH="0" baseline="0" dirty="0">
+                <a:ln>
+                  <a:noFill/>
+                </a:ln>
+                <a:solidFill>
+                  <a:schemeClr val="tx1"/>
+                </a:solidFill>
+                <a:effectLst/>
+                <a:latin typeface="Arial Unicode MS"/>
+              </a:rPr>
+              <a:t>	- </a:t>
+            </a:r>
+            <a:r>
+              <a:rPr kumimoji="0" lang="en-SI" altLang="en-SI" sz="1400" b="0" i="0" u="none" strike="noStrike" cap="none" normalizeH="0" baseline="0" dirty="0" err="1">
+                <a:ln>
+                  <a:noFill/>
+                </a:ln>
+                <a:solidFill>
+                  <a:schemeClr val="tx1"/>
+                </a:solidFill>
+                <a:effectLst/>
+                <a:latin typeface="Arial Unicode MS"/>
+              </a:rPr>
+              <a:t>lat_error</a:t>
+            </a:r>
+            <a:r>
+              <a:rPr kumimoji="0" lang="en-SI" altLang="en-SI" sz="1400" b="0" i="0" u="none" strike="noStrike" cap="none" normalizeH="0" baseline="0" dirty="0">
+                <a:ln>
+                  <a:noFill/>
+                </a:ln>
+                <a:solidFill>
+                  <a:schemeClr val="tx1"/>
+                </a:solidFill>
+                <a:effectLst/>
+                <a:latin typeface="Arial Unicode MS"/>
+              </a:rPr>
+              <a:t> = (latency − </a:t>
+            </a:r>
+            <a:r>
+              <a:rPr kumimoji="0" lang="en-SI" altLang="en-SI" sz="1400" b="0" i="0" u="none" strike="noStrike" cap="none" normalizeH="0" baseline="0" dirty="0" err="1">
+                <a:ln>
+                  <a:noFill/>
+                </a:ln>
+                <a:solidFill>
+                  <a:schemeClr val="tx1"/>
+                </a:solidFill>
+                <a:effectLst/>
+                <a:latin typeface="Arial Unicode MS"/>
+              </a:rPr>
+              <a:t>target_latency</a:t>
+            </a:r>
+            <a:r>
+              <a:rPr kumimoji="0" lang="en-SI" altLang="en-SI" sz="1400" b="0" i="0" u="none" strike="noStrike" cap="none" normalizeH="0" baseline="0" dirty="0">
+                <a:ln>
+                  <a:noFill/>
+                </a:ln>
+                <a:solidFill>
+                  <a:schemeClr val="tx1"/>
+                </a:solidFill>
+                <a:effectLst/>
+                <a:latin typeface="Arial Unicode MS"/>
+              </a:rPr>
+              <a:t>) / </a:t>
+            </a:r>
+            <a:r>
+              <a:rPr kumimoji="0" lang="en-SI" altLang="en-SI" sz="1400" b="0" i="0" u="none" strike="noStrike" cap="none" normalizeH="0" baseline="0" dirty="0" err="1">
+                <a:ln>
+                  <a:noFill/>
+                </a:ln>
+                <a:solidFill>
+                  <a:schemeClr val="tx1"/>
+                </a:solidFill>
+                <a:effectLst/>
+                <a:latin typeface="Arial Unicode MS"/>
+              </a:rPr>
+              <a:t>target_latency</a:t>
+            </a:r>
+            <a:endParaRPr kumimoji="0" lang="en-US" altLang="en-SI" sz="1400" b="0" i="0" u="none" strike="noStrike" cap="none" normalizeH="0" baseline="0" dirty="0">
+              <a:ln>
+                <a:noFill/>
+              </a:ln>
+              <a:solidFill>
+                <a:schemeClr val="tx1"/>
+              </a:solidFill>
+              <a:effectLst/>
+              <a:latin typeface="Arial Unicode MS"/>
+            </a:endParaRPr>
+          </a:p>
+          <a:p>
+            <a:pPr marL="0" marR="0" lvl="0" indent="0" algn="l" defTabSz="914400" rtl="0" eaLnBrk="0" fontAlgn="base" latinLnBrk="0" hangingPunct="0">
+              <a:lnSpc>
+                <a:spcPct val="100000"/>
+              </a:lnSpc>
+              <a:spcBef>
+                <a:spcPct val="0"/>
+              </a:spcBef>
+              <a:spcAft>
+                <a:spcPct val="0"/>
+              </a:spcAft>
+              <a:buClrTx/>
+              <a:buSzTx/>
+              <a:tabLst/>
+            </a:pPr>
+            <a:endParaRPr kumimoji="0" lang="en-SI" altLang="en-SI" sz="1400" b="0" i="0" u="none" strike="noStrike" cap="none" normalizeH="0" baseline="0" dirty="0">
+              <a:ln>
+                <a:noFill/>
+              </a:ln>
+              <a:solidFill>
+                <a:schemeClr val="tx1"/>
+              </a:solidFill>
+              <a:effectLst/>
+            </a:endParaRPr>
+          </a:p>
+          <a:p>
+            <a:pPr marL="285750" marR="0" lvl="0" indent="-285750" algn="l" defTabSz="914400" rtl="0" eaLnBrk="0" fontAlgn="base" latinLnBrk="0" hangingPunct="0">
+              <a:lnSpc>
+                <a:spcPct val="100000"/>
+              </a:lnSpc>
+              <a:spcBef>
+                <a:spcPct val="0"/>
+              </a:spcBef>
+              <a:spcAft>
+                <a:spcPct val="0"/>
+              </a:spcAft>
+              <a:buClrTx/>
+              <a:buSzTx/>
+              <a:buFont typeface="Arial" panose="020B0604020202020204" pitchFamily="34" charset="0"/>
+              <a:buChar char="•"/>
+              <a:tabLst/>
+            </a:pPr>
+            <a:r>
+              <a:rPr kumimoji="0" lang="en-SI" altLang="en-SI" sz="1400" b="1" i="0" u="none" strike="noStrike" cap="none" normalizeH="0" baseline="0" dirty="0">
+                <a:ln>
+                  <a:noFill/>
+                </a:ln>
+                <a:solidFill>
+                  <a:schemeClr val="tx1"/>
+                </a:solidFill>
+                <a:effectLst/>
+                <a:latin typeface="Arial" panose="020B0604020202020204" pitchFamily="34" charset="0"/>
+              </a:rPr>
+              <a:t>Decision layer</a:t>
+            </a:r>
+            <a:endParaRPr kumimoji="0" lang="en-SI" altLang="en-SI" sz="1400" b="0" i="0" u="none" strike="noStrike" cap="none" normalizeH="0" baseline="0" dirty="0">
+              <a:ln>
+                <a:noFill/>
+              </a:ln>
+              <a:solidFill>
+                <a:schemeClr val="tx1"/>
+              </a:solidFill>
+              <a:effectLst/>
+              <a:latin typeface="Arial" panose="020B0604020202020204" pitchFamily="34" charset="0"/>
+            </a:endParaRPr>
+          </a:p>
+          <a:p>
+            <a:pPr marL="0" marR="0" lvl="0" indent="0" algn="l" defTabSz="914400" rtl="0" eaLnBrk="0" fontAlgn="base" latinLnBrk="0" hangingPunct="0">
+              <a:lnSpc>
+                <a:spcPct val="100000"/>
+              </a:lnSpc>
+              <a:spcBef>
+                <a:spcPct val="0"/>
+              </a:spcBef>
+              <a:spcAft>
+                <a:spcPct val="0"/>
+              </a:spcAft>
+              <a:buClrTx/>
+              <a:buSzTx/>
+              <a:tabLst/>
+            </a:pPr>
+            <a:r>
+              <a:rPr kumimoji="0" lang="en-US" altLang="en-SI" sz="1400" b="0" i="0" u="none" strike="noStrike" cap="none" normalizeH="0" baseline="0" dirty="0">
+                <a:ln>
+                  <a:noFill/>
+                </a:ln>
+                <a:solidFill>
+                  <a:schemeClr val="tx1"/>
+                </a:solidFill>
+                <a:effectLst/>
+                <a:latin typeface="Arial" panose="020B0604020202020204" pitchFamily="34" charset="0"/>
+              </a:rPr>
+              <a:t>	- </a:t>
+            </a:r>
+            <a:r>
+              <a:rPr kumimoji="0" lang="en-SI" altLang="en-SI" sz="1400" b="0" i="0" u="none" strike="noStrike" cap="none" normalizeH="0" baseline="0" dirty="0">
+                <a:ln>
+                  <a:noFill/>
+                </a:ln>
+                <a:solidFill>
+                  <a:schemeClr val="tx1"/>
+                </a:solidFill>
+                <a:effectLst/>
+                <a:latin typeface="Arial" panose="020B0604020202020204" pitchFamily="34" charset="0"/>
+              </a:rPr>
+              <a:t>If any constraint violated → </a:t>
+            </a:r>
+            <a:r>
+              <a:rPr kumimoji="0" lang="en-SI" altLang="en-SI" sz="1400" b="1" i="0" u="none" strike="noStrike" cap="none" normalizeH="0" baseline="0" dirty="0">
+                <a:ln>
+                  <a:noFill/>
+                </a:ln>
+                <a:solidFill>
+                  <a:schemeClr val="tx1"/>
+                </a:solidFill>
+                <a:effectLst/>
+                <a:latin typeface="Arial" panose="020B0604020202020204" pitchFamily="34" charset="0"/>
+              </a:rPr>
+              <a:t>Feasibility mode</a:t>
+            </a:r>
+            <a:endParaRPr kumimoji="0" lang="en-SI" altLang="en-SI" sz="1400" b="0" i="0" u="none" strike="noStrike" cap="none" normalizeH="0" baseline="0" dirty="0">
+              <a:ln>
+                <a:noFill/>
+              </a:ln>
+              <a:solidFill>
+                <a:schemeClr val="tx1"/>
+              </a:solidFill>
+              <a:effectLst/>
+              <a:latin typeface="Arial" panose="020B0604020202020204" pitchFamily="34" charset="0"/>
+            </a:endParaRPr>
+          </a:p>
+          <a:p>
+            <a:pPr marL="457200" lvl="8" algn="l" rtl="0" eaLnBrk="0" fontAlgn="base" hangingPunct="0">
+              <a:spcBef>
+                <a:spcPct val="0"/>
+              </a:spcBef>
+              <a:spcAft>
+                <a:spcPct val="0"/>
+              </a:spcAft>
+            </a:pPr>
+            <a:r>
+              <a:rPr kumimoji="0" lang="en-US" altLang="en-SI" sz="1400" b="0" i="0" u="none" strike="noStrike" cap="none" normalizeH="0" baseline="0" dirty="0">
+                <a:ln>
+                  <a:noFill/>
+                </a:ln>
+                <a:solidFill>
+                  <a:schemeClr val="tx1"/>
+                </a:solidFill>
+                <a:effectLst/>
+                <a:latin typeface="Arial" panose="020B0604020202020204" pitchFamily="34" charset="0"/>
+              </a:rPr>
+              <a:t>		&gt; </a:t>
+            </a:r>
+            <a:r>
+              <a:rPr kumimoji="0" lang="en-SI" altLang="en-SI" sz="1400" b="0" i="0" u="none" strike="noStrike" cap="none" normalizeH="0" baseline="0" dirty="0">
+                <a:ln>
+                  <a:noFill/>
+                </a:ln>
+                <a:solidFill>
+                  <a:schemeClr val="tx1"/>
+                </a:solidFill>
+                <a:effectLst/>
+                <a:latin typeface="Arial" panose="020B0604020202020204" pitchFamily="34" charset="0"/>
+              </a:rPr>
+              <a:t>Run PID update for violated metric</a:t>
+            </a:r>
+            <a:r>
+              <a:rPr kumimoji="0" lang="en-US" altLang="en-SI" sz="1400" b="0" i="0" u="none" strike="noStrike" cap="none" normalizeH="0" baseline="0" dirty="0">
+                <a:ln>
+                  <a:noFill/>
+                </a:ln>
+                <a:solidFill>
+                  <a:schemeClr val="tx1"/>
+                </a:solidFill>
+                <a:effectLst/>
+                <a:latin typeface="Arial" panose="020B0604020202020204" pitchFamily="34" charset="0"/>
+              </a:rPr>
+              <a:t>s</a:t>
+            </a:r>
+            <a:endParaRPr kumimoji="0" lang="en-SI" altLang="en-SI" sz="1400" b="0" i="0" u="none" strike="noStrike" cap="none" normalizeH="0" baseline="0" dirty="0">
+              <a:ln>
+                <a:noFill/>
+              </a:ln>
+              <a:solidFill>
+                <a:schemeClr val="tx1"/>
+              </a:solidFill>
+              <a:effectLst/>
+              <a:latin typeface="Arial" panose="020B0604020202020204" pitchFamily="34" charset="0"/>
+            </a:endParaRPr>
+          </a:p>
+          <a:p>
+            <a:pPr marL="457200" lvl="3" algn="l" rtl="0" eaLnBrk="0" fontAlgn="base" hangingPunct="0">
+              <a:spcBef>
+                <a:spcPct val="0"/>
+              </a:spcBef>
+              <a:spcAft>
+                <a:spcPct val="0"/>
+              </a:spcAft>
+            </a:pPr>
+            <a:r>
+              <a:rPr kumimoji="0" lang="en-US" altLang="en-SI" sz="1400" b="0" i="0" u="none" strike="noStrike" cap="none" normalizeH="0" baseline="0" dirty="0">
+                <a:ln>
+                  <a:noFill/>
+                </a:ln>
+                <a:solidFill>
+                  <a:schemeClr val="tx1"/>
+                </a:solidFill>
+                <a:effectLst/>
+                <a:latin typeface="Arial" panose="020B0604020202020204" pitchFamily="34" charset="0"/>
+              </a:rPr>
+              <a:t>		&gt; </a:t>
+            </a:r>
+            <a:r>
+              <a:rPr kumimoji="0" lang="en-SI" altLang="en-SI" sz="1400" b="0" i="0" u="none" strike="noStrike" cap="none" normalizeH="0" baseline="0" dirty="0">
+                <a:ln>
+                  <a:noFill/>
+                </a:ln>
+                <a:solidFill>
+                  <a:schemeClr val="tx1"/>
+                </a:solidFill>
+                <a:effectLst/>
+                <a:latin typeface="Arial" panose="020B0604020202020204" pitchFamily="34" charset="0"/>
+              </a:rPr>
+              <a:t>Apply </a:t>
+            </a:r>
+            <a:r>
+              <a:rPr kumimoji="0" lang="en-SI" altLang="en-SI" sz="1400" b="1" i="0" u="none" strike="noStrike" cap="none" normalizeH="0" baseline="0" dirty="0">
+                <a:ln>
+                  <a:noFill/>
+                </a:ln>
+                <a:solidFill>
+                  <a:schemeClr val="tx1"/>
+                </a:solidFill>
+                <a:effectLst/>
+                <a:latin typeface="Arial" panose="020B0604020202020204" pitchFamily="34" charset="0"/>
+              </a:rPr>
+              <a:t>frequency adjustment</a:t>
+            </a:r>
+            <a:r>
+              <a:rPr kumimoji="0" lang="en-SI" altLang="en-SI" sz="1400" b="0" i="0" u="none" strike="noStrike" cap="none" normalizeH="0" baseline="0" dirty="0">
+                <a:ln>
+                  <a:noFill/>
+                </a:ln>
+                <a:solidFill>
+                  <a:schemeClr val="tx1"/>
+                </a:solidFill>
+                <a:effectLst/>
+                <a:latin typeface="Arial" panose="020B0604020202020204" pitchFamily="34" charset="0"/>
+              </a:rPr>
+              <a:t> (clamped to valid DVFS steps)</a:t>
+            </a:r>
+          </a:p>
+          <a:p>
+            <a:pPr marL="457200" lvl="3" algn="l" rtl="0" eaLnBrk="0" fontAlgn="base" hangingPunct="0">
+              <a:spcBef>
+                <a:spcPct val="0"/>
+              </a:spcBef>
+              <a:spcAft>
+                <a:spcPct val="0"/>
+              </a:spcAft>
+            </a:pPr>
+            <a:r>
+              <a:rPr kumimoji="0" lang="en-US" altLang="en-SI" sz="1400" b="0" i="0" u="none" strike="noStrike" cap="none" normalizeH="0" baseline="0" dirty="0">
+                <a:ln>
+                  <a:noFill/>
+                </a:ln>
+                <a:solidFill>
+                  <a:schemeClr val="tx1"/>
+                </a:solidFill>
+                <a:effectLst/>
+                <a:latin typeface="Arial" panose="020B0604020202020204" pitchFamily="34" charset="0"/>
+              </a:rPr>
+              <a:t>		&gt; </a:t>
+            </a:r>
+            <a:r>
+              <a:rPr kumimoji="0" lang="en-SI" altLang="en-SI" sz="1400" b="0" i="0" u="none" strike="noStrike" cap="none" normalizeH="0" baseline="0" dirty="0">
+                <a:ln>
+                  <a:noFill/>
+                </a:ln>
+                <a:solidFill>
+                  <a:schemeClr val="tx1"/>
+                </a:solidFill>
+                <a:effectLst/>
+                <a:latin typeface="Arial" panose="020B0604020202020204" pitchFamily="34" charset="0"/>
+              </a:rPr>
+              <a:t>If frequencies saturated / unstable → </a:t>
+            </a:r>
+            <a:r>
+              <a:rPr kumimoji="0" lang="en-SI" altLang="en-SI" sz="1400" b="1" i="0" u="none" strike="noStrike" cap="none" normalizeH="0" baseline="0" dirty="0">
+                <a:ln>
+                  <a:noFill/>
+                </a:ln>
+                <a:solidFill>
+                  <a:schemeClr val="tx1"/>
+                </a:solidFill>
+                <a:effectLst/>
+                <a:latin typeface="Arial" panose="020B0604020202020204" pitchFamily="34" charset="0"/>
+              </a:rPr>
+              <a:t>adjust partitions</a:t>
+            </a:r>
+            <a:r>
+              <a:rPr kumimoji="0" lang="en-SI" altLang="en-SI" sz="1400" b="0" i="0" u="none" strike="noStrike" cap="none" normalizeH="0" baseline="0" dirty="0">
+                <a:ln>
+                  <a:noFill/>
+                </a:ln>
+                <a:solidFill>
+                  <a:schemeClr val="tx1"/>
+                </a:solidFill>
+                <a:effectLst/>
+                <a:latin typeface="Arial" panose="020B0604020202020204" pitchFamily="34" charset="0"/>
+              </a:rPr>
+              <a:t> using bottleneck stage</a:t>
+            </a:r>
+            <a:endParaRPr kumimoji="0" lang="en-US" altLang="en-SI" sz="1400" b="0" i="0" u="none" strike="noStrike" cap="none" normalizeH="0" baseline="0" dirty="0">
+              <a:ln>
+                <a:noFill/>
+              </a:ln>
+              <a:solidFill>
+                <a:schemeClr val="tx1"/>
+              </a:solidFill>
+              <a:effectLst/>
+              <a:latin typeface="Arial" panose="020B0604020202020204" pitchFamily="34" charset="0"/>
+            </a:endParaRPr>
+          </a:p>
+          <a:p>
+            <a:pPr marL="457200" lvl="3" algn="l" rtl="0" eaLnBrk="0" fontAlgn="base" hangingPunct="0">
+              <a:spcBef>
+                <a:spcPct val="0"/>
+              </a:spcBef>
+              <a:spcAft>
+                <a:spcPct val="0"/>
+              </a:spcAft>
+            </a:pPr>
+            <a:endParaRPr kumimoji="0" lang="en-SI" altLang="en-SI" sz="1400" b="0" i="0" u="none" strike="noStrike" cap="none" normalizeH="0" baseline="0" dirty="0">
+              <a:ln>
+                <a:noFill/>
+              </a:ln>
+              <a:solidFill>
+                <a:schemeClr val="tx1"/>
+              </a:solidFill>
+              <a:effectLst/>
+              <a:latin typeface="Arial" panose="020B0604020202020204" pitchFamily="34" charset="0"/>
+            </a:endParaRPr>
+          </a:p>
+          <a:p>
+            <a:pPr marL="0" marR="0" lvl="0" indent="0" algn="l" defTabSz="914400" rtl="0" eaLnBrk="0" fontAlgn="base" latinLnBrk="0" hangingPunct="0">
+              <a:lnSpc>
+                <a:spcPct val="100000"/>
+              </a:lnSpc>
+              <a:spcBef>
+                <a:spcPct val="0"/>
+              </a:spcBef>
+              <a:spcAft>
+                <a:spcPct val="0"/>
+              </a:spcAft>
+              <a:buClrTx/>
+              <a:buSzTx/>
+              <a:tabLst/>
+            </a:pPr>
+            <a:r>
+              <a:rPr kumimoji="0" lang="en-US" altLang="en-SI" sz="1400" b="0" i="0" u="none" strike="noStrike" cap="none" normalizeH="0" baseline="0" dirty="0">
+                <a:ln>
+                  <a:noFill/>
+                </a:ln>
+                <a:solidFill>
+                  <a:schemeClr val="tx1"/>
+                </a:solidFill>
+                <a:effectLst/>
+                <a:latin typeface="Arial" panose="020B0604020202020204" pitchFamily="34" charset="0"/>
+              </a:rPr>
+              <a:t>	- </a:t>
+            </a:r>
+            <a:r>
+              <a:rPr kumimoji="0" lang="en-SI" altLang="en-SI" sz="1400" b="0" i="0" u="none" strike="noStrike" cap="none" normalizeH="0" baseline="0" dirty="0">
+                <a:ln>
+                  <a:noFill/>
+                </a:ln>
+                <a:solidFill>
+                  <a:schemeClr val="tx1"/>
+                </a:solidFill>
+                <a:effectLst/>
+                <a:latin typeface="Arial" panose="020B0604020202020204" pitchFamily="34" charset="0"/>
+              </a:rPr>
+              <a:t>If both constraints met → </a:t>
+            </a:r>
+            <a:r>
+              <a:rPr kumimoji="0" lang="en-SI" altLang="en-SI" sz="1400" b="1" i="0" u="none" strike="noStrike" cap="none" normalizeH="0" baseline="0" dirty="0">
+                <a:ln>
+                  <a:noFill/>
+                </a:ln>
+                <a:solidFill>
+                  <a:schemeClr val="tx1"/>
+                </a:solidFill>
+                <a:effectLst/>
+                <a:latin typeface="Arial" panose="020B0604020202020204" pitchFamily="34" charset="0"/>
+              </a:rPr>
+              <a:t>Power-reduce mode</a:t>
+            </a:r>
+            <a:endParaRPr kumimoji="0" lang="en-SI" altLang="en-SI" sz="1400" b="0" i="0" u="none" strike="noStrike" cap="none" normalizeH="0" baseline="0" dirty="0">
+              <a:ln>
+                <a:noFill/>
+              </a:ln>
+              <a:solidFill>
+                <a:schemeClr val="tx1"/>
+              </a:solidFill>
+              <a:effectLst/>
+              <a:latin typeface="Arial" panose="020B0604020202020204" pitchFamily="34" charset="0"/>
+            </a:endParaRPr>
+          </a:p>
+          <a:p>
+            <a:pPr marL="457200" marR="0" lvl="1" indent="0" algn="l" defTabSz="914400" rtl="0" eaLnBrk="0" fontAlgn="base" latinLnBrk="0" hangingPunct="0">
+              <a:lnSpc>
+                <a:spcPct val="100000"/>
+              </a:lnSpc>
+              <a:spcBef>
+                <a:spcPct val="0"/>
+              </a:spcBef>
+              <a:spcAft>
+                <a:spcPct val="0"/>
+              </a:spcAft>
+              <a:buClrTx/>
+              <a:buSzTx/>
+              <a:tabLst/>
+            </a:pPr>
+            <a:r>
+              <a:rPr kumimoji="0" lang="en-US" altLang="en-SI" sz="1400" b="0" i="0" u="none" strike="noStrike" cap="none" normalizeH="0" baseline="0" dirty="0">
+                <a:ln>
+                  <a:noFill/>
+                </a:ln>
+                <a:solidFill>
+                  <a:schemeClr val="tx1"/>
+                </a:solidFill>
+                <a:effectLst/>
+                <a:latin typeface="Arial" panose="020B0604020202020204" pitchFamily="34" charset="0"/>
+              </a:rPr>
+              <a:t>		&gt; </a:t>
+            </a:r>
+            <a:r>
+              <a:rPr kumimoji="0" lang="en-SI" altLang="en-SI" sz="1400" b="0" i="0" u="none" strike="noStrike" cap="none" normalizeH="0" baseline="0" dirty="0">
+                <a:ln>
+                  <a:noFill/>
+                </a:ln>
+                <a:solidFill>
+                  <a:schemeClr val="tx1"/>
+                </a:solidFill>
+                <a:effectLst/>
+                <a:latin typeface="Arial" panose="020B0604020202020204" pitchFamily="34" charset="0"/>
+              </a:rPr>
+              <a:t>Compute margins (FPS slack, latency slack)</a:t>
+            </a:r>
+          </a:p>
+          <a:p>
+            <a:pPr marL="457200" marR="0" lvl="1" indent="0" algn="l" defTabSz="914400" rtl="0" eaLnBrk="0" fontAlgn="base" latinLnBrk="0" hangingPunct="0">
+              <a:lnSpc>
+                <a:spcPct val="100000"/>
+              </a:lnSpc>
+              <a:spcBef>
+                <a:spcPct val="0"/>
+              </a:spcBef>
+              <a:spcAft>
+                <a:spcPct val="0"/>
+              </a:spcAft>
+              <a:buClrTx/>
+              <a:buSzTx/>
+              <a:tabLst/>
+            </a:pPr>
+            <a:r>
+              <a:rPr kumimoji="0" lang="en-US" altLang="en-SI" sz="1400" b="0" i="0" u="none" strike="noStrike" cap="none" normalizeH="0" baseline="0" dirty="0">
+                <a:ln>
+                  <a:noFill/>
+                </a:ln>
+                <a:solidFill>
+                  <a:schemeClr val="tx1"/>
+                </a:solidFill>
+                <a:effectLst/>
+                <a:latin typeface="Arial" panose="020B0604020202020204" pitchFamily="34" charset="0"/>
+              </a:rPr>
+              <a:t>		&gt; </a:t>
+            </a:r>
+            <a:r>
+              <a:rPr kumimoji="0" lang="en-SI" altLang="en-SI" sz="1400" b="0" i="0" u="none" strike="noStrike" cap="none" normalizeH="0" baseline="0" dirty="0">
+                <a:ln>
+                  <a:noFill/>
+                </a:ln>
+                <a:solidFill>
+                  <a:schemeClr val="tx1"/>
+                </a:solidFill>
+                <a:effectLst/>
+                <a:latin typeface="Arial" panose="020B0604020202020204" pitchFamily="34" charset="0"/>
+              </a:rPr>
+              <a:t>Reduce power with small steps (DVFS first, then partitions if safe)</a:t>
+            </a:r>
+            <a:endParaRPr kumimoji="0" lang="en-US" altLang="en-SI" sz="1400" b="0" i="0" u="none" strike="noStrike" cap="none" normalizeH="0" baseline="0" dirty="0">
+              <a:ln>
+                <a:noFill/>
+              </a:ln>
+              <a:solidFill>
+                <a:schemeClr val="tx1"/>
+              </a:solidFill>
+              <a:effectLst/>
+              <a:latin typeface="Arial" panose="020B0604020202020204" pitchFamily="34" charset="0"/>
+            </a:endParaRPr>
+          </a:p>
+          <a:p>
+            <a:pPr marL="457200" marR="0" lvl="1" indent="0" algn="l" defTabSz="914400" rtl="0" eaLnBrk="0" fontAlgn="base" latinLnBrk="0" hangingPunct="0">
+              <a:lnSpc>
+                <a:spcPct val="100000"/>
+              </a:lnSpc>
+              <a:spcBef>
+                <a:spcPct val="0"/>
+              </a:spcBef>
+              <a:spcAft>
+                <a:spcPct val="0"/>
+              </a:spcAft>
+              <a:buClrTx/>
+              <a:buSzTx/>
+              <a:tabLst/>
+            </a:pPr>
+            <a:endParaRPr kumimoji="0" lang="en-SI" altLang="en-SI" sz="1400" b="0" i="0" u="none" strike="noStrike" cap="none" normalizeH="0" baseline="0" dirty="0">
+              <a:ln>
+                <a:noFill/>
+              </a:ln>
+              <a:solidFill>
+                <a:schemeClr val="tx1"/>
+              </a:solidFill>
+              <a:effectLst/>
+              <a:latin typeface="Arial" panose="020B0604020202020204" pitchFamily="34" charset="0"/>
+            </a:endParaRPr>
+          </a:p>
+          <a:p>
+            <a:pPr marL="285750" marR="0" lvl="0" indent="-285750" algn="l" defTabSz="914400" rtl="0" eaLnBrk="0" fontAlgn="base" latinLnBrk="0" hangingPunct="0">
+              <a:lnSpc>
+                <a:spcPct val="100000"/>
+              </a:lnSpc>
+              <a:spcBef>
+                <a:spcPct val="0"/>
+              </a:spcBef>
+              <a:spcAft>
+                <a:spcPct val="0"/>
+              </a:spcAft>
+              <a:buClrTx/>
+              <a:buSzTx/>
+              <a:buFont typeface="Arial" panose="020B0604020202020204" pitchFamily="34" charset="0"/>
+              <a:buChar char="•"/>
+              <a:tabLst/>
+            </a:pPr>
+            <a:r>
+              <a:rPr kumimoji="0" lang="en-SI" altLang="en-SI" sz="1400" b="1" i="0" u="none" strike="noStrike" cap="none" normalizeH="0" baseline="0" dirty="0">
+                <a:ln>
+                  <a:noFill/>
+                </a:ln>
+                <a:solidFill>
+                  <a:schemeClr val="tx1"/>
+                </a:solidFill>
+                <a:effectLst/>
+                <a:latin typeface="Arial" panose="020B0604020202020204" pitchFamily="34" charset="0"/>
+              </a:rPr>
+              <a:t>Bottleneck-aware partitioning</a:t>
+            </a:r>
+            <a:endParaRPr kumimoji="0" lang="en-SI" altLang="en-SI" sz="1400" b="0" i="0" u="none" strike="noStrike" cap="none" normalizeH="0" baseline="0" dirty="0">
+              <a:ln>
+                <a:noFill/>
+              </a:ln>
+              <a:solidFill>
+                <a:schemeClr val="tx1"/>
+              </a:solidFill>
+              <a:effectLst/>
+              <a:latin typeface="Arial" panose="020B0604020202020204" pitchFamily="34" charset="0"/>
+            </a:endParaRPr>
+          </a:p>
+          <a:p>
+            <a:pPr marL="0" marR="0" lvl="0" indent="0" algn="l" defTabSz="914400" rtl="0" eaLnBrk="0" fontAlgn="base" latinLnBrk="0" hangingPunct="0">
+              <a:lnSpc>
+                <a:spcPct val="100000"/>
+              </a:lnSpc>
+              <a:spcBef>
+                <a:spcPct val="0"/>
+              </a:spcBef>
+              <a:spcAft>
+                <a:spcPct val="0"/>
+              </a:spcAft>
+              <a:buClrTx/>
+              <a:buSzTx/>
+              <a:tabLst/>
+            </a:pPr>
+            <a:r>
+              <a:rPr kumimoji="0" lang="en-US" altLang="en-SI" sz="1400" b="0" i="0" u="none" strike="noStrike" cap="none" normalizeH="0" baseline="0" dirty="0">
+                <a:ln>
+                  <a:noFill/>
+                </a:ln>
+                <a:solidFill>
+                  <a:schemeClr val="tx1"/>
+                </a:solidFill>
+                <a:effectLst/>
+                <a:latin typeface="Arial" panose="020B0604020202020204" pitchFamily="34" charset="0"/>
+              </a:rPr>
+              <a:t>	- </a:t>
+            </a:r>
+            <a:r>
+              <a:rPr kumimoji="0" lang="en-SI" altLang="en-SI" sz="1400" b="0" i="0" u="none" strike="noStrike" cap="none" normalizeH="0" baseline="0" dirty="0">
+                <a:ln>
+                  <a:noFill/>
+                </a:ln>
+                <a:solidFill>
+                  <a:schemeClr val="tx1"/>
+                </a:solidFill>
+                <a:effectLst/>
+                <a:latin typeface="Arial" panose="020B0604020202020204" pitchFamily="34" charset="0"/>
+              </a:rPr>
+              <a:t>Throughput dominated by </a:t>
+            </a:r>
+            <a:r>
+              <a:rPr kumimoji="0" lang="en-SI" altLang="en-SI" sz="1400" b="0" i="0" u="none" strike="noStrike" cap="none" normalizeH="0" baseline="0" dirty="0">
+                <a:ln>
+                  <a:noFill/>
+                </a:ln>
+                <a:solidFill>
+                  <a:schemeClr val="tx1"/>
+                </a:solidFill>
+                <a:effectLst/>
+                <a:latin typeface="Arial Unicode MS"/>
+              </a:rPr>
+              <a:t>max(T1, T2, T3)</a:t>
+            </a:r>
+            <a:endParaRPr kumimoji="0" lang="en-SI" altLang="en-SI" sz="1400" b="0" i="0" u="none" strike="noStrike" cap="none" normalizeH="0" baseline="0" dirty="0">
+              <a:ln>
+                <a:noFill/>
+              </a:ln>
+              <a:solidFill>
+                <a:schemeClr val="tx1"/>
+              </a:solidFill>
+              <a:effectLst/>
+            </a:endParaRPr>
+          </a:p>
+          <a:p>
+            <a:pPr marL="0" marR="0" lvl="0" indent="0" algn="l" defTabSz="914400" rtl="0" eaLnBrk="0" fontAlgn="base" latinLnBrk="0" hangingPunct="0">
+              <a:lnSpc>
+                <a:spcPct val="100000"/>
+              </a:lnSpc>
+              <a:spcBef>
+                <a:spcPct val="0"/>
+              </a:spcBef>
+              <a:spcAft>
+                <a:spcPct val="0"/>
+              </a:spcAft>
+              <a:buClrTx/>
+              <a:buSzTx/>
+              <a:tabLst/>
+            </a:pPr>
+            <a:r>
+              <a:rPr kumimoji="0" lang="en-US" altLang="en-SI" sz="1400" b="0" i="0" u="none" strike="noStrike" cap="none" normalizeH="0" baseline="0" dirty="0">
+                <a:ln>
+                  <a:noFill/>
+                </a:ln>
+                <a:solidFill>
+                  <a:schemeClr val="tx1"/>
+                </a:solidFill>
+                <a:effectLst/>
+                <a:latin typeface="Arial" panose="020B0604020202020204" pitchFamily="34" charset="0"/>
+              </a:rPr>
+              <a:t>	- </a:t>
+            </a:r>
+            <a:r>
+              <a:rPr kumimoji="0" lang="en-SI" altLang="en-SI" sz="1400" b="0" i="0" u="none" strike="noStrike" cap="none" normalizeH="0" baseline="0" dirty="0">
+                <a:ln>
+                  <a:noFill/>
+                </a:ln>
+                <a:solidFill>
+                  <a:schemeClr val="tx1"/>
+                </a:solidFill>
+                <a:effectLst/>
+                <a:latin typeface="Arial" panose="020B0604020202020204" pitchFamily="34" charset="0"/>
+              </a:rPr>
+              <a:t>Shift work away from bottleneck component (avoid 1-layer stages)</a:t>
+            </a:r>
+          </a:p>
+          <a:p>
+            <a:pPr marL="0" marR="0" lvl="0" indent="0" algn="l" defTabSz="914400" rtl="0" eaLnBrk="0" fontAlgn="base" latinLnBrk="0" hangingPunct="0">
+              <a:lnSpc>
+                <a:spcPct val="100000"/>
+              </a:lnSpc>
+              <a:spcBef>
+                <a:spcPct val="0"/>
+              </a:spcBef>
+              <a:spcAft>
+                <a:spcPct val="0"/>
+              </a:spcAft>
+              <a:buClrTx/>
+              <a:buSzTx/>
+              <a:buFontTx/>
               <a:buNone/>
-            </a:pPr>
-            <a:endParaRPr b="0" lang="en-US" sz="3200" spc="-1" strike="noStrike">
+              <a:tabLst/>
+            </a:pPr>
+            <a:endParaRPr kumimoji="0" lang="en-SI" altLang="en-SI" sz="1800" b="0" i="0" u="none" strike="noStrike" cap="none" normalizeH="0" baseline="0" dirty="0">
+              <a:ln>
+                <a:noFill/>
+              </a:ln>
               <a:solidFill>
-                <a:srgbClr val="000000"/>
+                <a:schemeClr val="tx1"/>
               </a:solidFill>
-              <a:latin typeface="Arial"/>
+              <a:effectLst/>
+              <a:latin typeface="Arial" panose="020B0604020202020204" pitchFamily="34" charset="0"/>
             </a:endParaRPr>
           </a:p>
         </p:txBody>
       </p:sp>
     </p:spTree>
   </p:cSld>
-  <mc:AlternateContent>
-    <mc:Choice Requires="p14">
-      <p:transition spd="slow" p14:dur="2000"/>
-    </mc:Choice>
-    <mc:Fallback>
-      <p:transition spd="slow"/>
-    </mc:Fallback>
-  </mc:AlternateContent>
+  <p:clrMapOvr>
+    <a:masterClrMapping/>
+  </p:clrMapOvr>
 </p:sld>
 </file>
 
 <file path=ppt/slides/slide8.xml><?xml version="1.0" encoding="utf-8"?>
-<p:sld xmlns:a="http://schemas.openxmlformats.org/drawingml/2006/main" xmlns:p="http://schemas.openxmlformats.org/presentationml/2006/main" xmlns:r="http://schemas.openxmlformats.org/officeDocument/2006/relationships" xmlns:p14="http://schemas.microsoft.com/office/powerpoint/2010/main" xmlns:p15="http://schemas.microsoft.com/office/powerpoint/2012/main" xmlns:mc="http://schemas.openxmlformats.org/markup-compatibility/2006">
+<p:sld xmlns:a="http://schemas.openxmlformats.org/drawingml/2006/main" xmlns:r="http://schemas.openxmlformats.org/officeDocument/2006/relationships" xmlns:p="http://schemas.openxmlformats.org/presentationml/2006/main">
   <p:cSld>
     <p:spTree>
       <p:nvGrpSpPr>
@@ -2523,15 +3921,16 @@
           </a:ln>
         </p:spPr>
         <p:txBody>
-          <a:bodyPr lIns="0" rIns="0" tIns="0" bIns="0" anchor="ctr">
+          <a:bodyPr lIns="0" tIns="0" rIns="0" bIns="0" anchor="ctr">
             <a:noAutofit/>
           </a:bodyPr>
+          <a:lstStyle/>
           <a:p>
             <a:pPr indent="0" algn="ctr">
               <a:buNone/>
             </a:pPr>
             <a:r>
-              <a:rPr b="0" lang="en-US" sz="4400" spc="-1" strike="noStrike">
+              <a:rPr lang="en-US" sz="4400" b="0" strike="noStrike" spc="-1">
                 <a:solidFill>
                   <a:srgbClr val="000000"/>
                 </a:solidFill>
@@ -2539,12 +3938,6 @@
               </a:rPr>
               <a:t>Power Estimation Model</a:t>
             </a:r>
-            <a:endParaRPr b="0" lang="en-US" sz="4400" spc="-1" strike="noStrike">
-              <a:solidFill>
-                <a:srgbClr val="000000"/>
-              </a:solidFill>
-              <a:latin typeface="Arial"/>
-            </a:endParaRPr>
           </a:p>
         </p:txBody>
       </p:sp>
@@ -2572,9 +3965,10 @@
           </a:ln>
         </p:spPr>
         <p:txBody>
-          <a:bodyPr lIns="0" rIns="0" tIns="0" bIns="0" anchor="t">
-            <a:normAutofit fontScale="84133"/>
+          <a:bodyPr lIns="0" tIns="0" rIns="0" bIns="0" anchor="t">
+            <a:normAutofit fontScale="91633" lnSpcReduction="20000"/>
           </a:bodyPr>
+          <a:lstStyle/>
           <a:p>
             <a:pPr marL="432000" indent="-324000">
               <a:spcBef>
@@ -2588,7 +3982,7 @@
               <a:buChar char=""/>
             </a:pPr>
             <a:r>
-              <a:rPr b="0" lang="en-US" sz="2400" spc="-1" strike="noStrike">
+              <a:rPr lang="en-US" sz="2400" b="0" strike="noStrike" spc="-1" dirty="0">
                 <a:solidFill>
                   <a:srgbClr val="000000"/>
                 </a:solidFill>
@@ -2596,15 +3990,9 @@
               </a:rPr>
               <a:t>Simple rule derived from measurements</a:t>
             </a:r>
-            <a:endParaRPr b="0" lang="en-US" sz="2400" spc="-1" strike="noStrike">
-              <a:solidFill>
-                <a:srgbClr val="000000"/>
-              </a:solidFill>
-              <a:latin typeface="Arial"/>
-            </a:endParaRPr>
-          </a:p>
-          <a:p>
-            <a:pPr lvl="1" marL="864000" indent="-324000">
+          </a:p>
+          <a:p>
+            <a:pPr marL="864000" lvl="1" indent="-324000">
               <a:spcBef>
                 <a:spcPts val="1134"/>
               </a:spcBef>
@@ -2616,7 +4004,7 @@
               <a:buChar char=""/>
             </a:pPr>
             <a:r>
-              <a:rPr b="0" lang="en-US" sz="2400" spc="-1" strike="noStrike">
+              <a:rPr lang="en-US" sz="2400" b="0" strike="noStrike" spc="-1" dirty="0">
                 <a:solidFill>
                   <a:srgbClr val="000000"/>
                 </a:solidFill>
@@ -2624,15 +4012,9 @@
               </a:rPr>
               <a:t>Calculate a workload fraction for a specific component:</a:t>
             </a:r>
-            <a:endParaRPr b="0" lang="en-US" sz="2400" spc="-1" strike="noStrike">
-              <a:solidFill>
-                <a:srgbClr val="000000"/>
-              </a:solidFill>
-              <a:latin typeface="Arial"/>
-            </a:endParaRPr>
-          </a:p>
-          <a:p>
-            <a:pPr lvl="2" marL="1296000" indent="-288000">
+          </a:p>
+          <a:p>
+            <a:pPr marL="1296000" lvl="2" indent="-288000">
               <a:spcBef>
                 <a:spcPts val="850"/>
               </a:spcBef>
@@ -2644,24 +4026,51 @@
               <a:buChar char=""/>
             </a:pPr>
             <a:r>
-              <a:rPr b="0" lang="en-US" sz="1600" spc="-1" strike="noStrike">
+              <a:rPr lang="en-US" sz="1600" b="0" strike="noStrike" spc="-1" dirty="0" err="1">
                 <a:solidFill>
                   <a:srgbClr val="000000"/>
                 </a:solidFill>
                 <a:latin typeface="Consolas"/>
               </a:rPr>
-              <a:t>weighted_frac = frac_layers * </a:t>
-            </a:r>
-            <a:r>
-              <a:rPr b="0" lang="en-US" sz="1600" spc="-1" strike="noStrike">
-                <a:solidFill>
-                  <a:srgbClr val="00a933"/>
+              <a:t>weighted_frac</a:t>
+            </a:r>
+            <a:r>
+              <a:rPr lang="en-US" sz="1600" b="0" strike="noStrike" spc="-1" dirty="0">
+                <a:solidFill>
+                  <a:srgbClr val="000000"/>
                 </a:solidFill>
                 <a:latin typeface="Consolas"/>
               </a:rPr>
+              <a:t> = </a:t>
+            </a:r>
+            <a:r>
+              <a:rPr lang="en-US" sz="1600" b="0" strike="noStrike" spc="-1" dirty="0" err="1">
+                <a:solidFill>
+                  <a:srgbClr val="000000"/>
+                </a:solidFill>
+                <a:latin typeface="Consolas"/>
+              </a:rPr>
+              <a:t>frac_layers</a:t>
+            </a:r>
+            <a:r>
+              <a:rPr lang="en-US" sz="1600" b="0" strike="noStrike" spc="-1" dirty="0">
+                <a:solidFill>
+                  <a:srgbClr val="000000"/>
+                </a:solidFill>
+                <a:latin typeface="Consolas"/>
+              </a:rPr>
+              <a:t> * </a:t>
+            </a:r>
+            <a:r>
+              <a:rPr lang="en-US" sz="1600" b="0" strike="noStrike" spc="-1" dirty="0" err="1">
+                <a:solidFill>
+                  <a:srgbClr val="00A933"/>
+                </a:solidFill>
+                <a:latin typeface="Consolas"/>
+              </a:rPr>
               <a:t>alexnet_layer_computation_load</a:t>
             </a:r>
-            <a:endParaRPr b="0" lang="en-US" sz="1600" spc="-1" strike="noStrike">
+            <a:endParaRPr lang="en-US" sz="1600" b="0" strike="noStrike" spc="-1" dirty="0">
               <a:solidFill>
                 <a:srgbClr val="000000"/>
               </a:solidFill>
@@ -2669,7 +4078,7 @@
             </a:endParaRPr>
           </a:p>
           <a:p>
-            <a:pPr lvl="1" marL="864000" indent="-324000">
+            <a:pPr marL="864000" lvl="1" indent="-324000">
               <a:spcBef>
                 <a:spcPts val="1134"/>
               </a:spcBef>
@@ -2681,7 +4090,7 @@
               <a:buChar char=""/>
             </a:pPr>
             <a:r>
-              <a:rPr b="0" lang="en-US" sz="2400" spc="-1" strike="noStrike">
+              <a:rPr lang="en-US" sz="2400" b="0" strike="noStrike" spc="-1" dirty="0">
                 <a:solidFill>
                   <a:srgbClr val="000000"/>
                 </a:solidFill>
@@ -2690,24 +4099,105 @@
               <a:t>CPUs: </a:t>
             </a:r>
             <a:r>
-              <a:rPr b="0" lang="en-US" sz="1600" spc="-1" strike="noStrike">
+              <a:rPr lang="en-US" sz="1600" b="0" strike="noStrike" spc="-1" dirty="0">
                 <a:solidFill>
                   <a:srgbClr val="000000"/>
                 </a:solidFill>
                 <a:latin typeface="Consolas"/>
               </a:rPr>
-              <a:t>power(cpu) = weighted_frac(cpu) * </a:t>
-            </a:r>
-            <a:r>
-              <a:rPr b="0" lang="en-US" sz="1600" spc="-1" strike="noStrike">
-                <a:solidFill>
-                  <a:srgbClr val="c9211e"/>
+              <a:t>power(</a:t>
+            </a:r>
+            <a:r>
+              <a:rPr lang="en-US" sz="1600" b="0" strike="noStrike" spc="-1" dirty="0" err="1">
+                <a:solidFill>
+                  <a:srgbClr val="000000"/>
                 </a:solidFill>
                 <a:latin typeface="Consolas"/>
               </a:rPr>
-              <a:t>fx_power(cpu)</a:t>
-            </a:r>
-            <a:endParaRPr b="0" lang="en-US" sz="1600" spc="-1" strike="noStrike">
+              <a:t>cpu</a:t>
+            </a:r>
+            <a:r>
+              <a:rPr lang="en-US" sz="1600" b="0" strike="noStrike" spc="-1" dirty="0">
+                <a:solidFill>
+                  <a:srgbClr val="000000"/>
+                </a:solidFill>
+                <a:latin typeface="Consolas"/>
+              </a:rPr>
+              <a:t>) = </a:t>
+            </a:r>
+            <a:r>
+              <a:rPr lang="en-US" sz="1600" b="0" strike="noStrike" spc="-1" dirty="0" err="1">
+                <a:solidFill>
+                  <a:srgbClr val="000000"/>
+                </a:solidFill>
+                <a:latin typeface="Consolas"/>
+              </a:rPr>
+              <a:t>weighted_frac</a:t>
+            </a:r>
+            <a:r>
+              <a:rPr lang="en-US" sz="1600" b="0" strike="noStrike" spc="-1" dirty="0">
+                <a:solidFill>
+                  <a:srgbClr val="000000"/>
+                </a:solidFill>
+                <a:latin typeface="Consolas"/>
+              </a:rPr>
+              <a:t>(</a:t>
+            </a:r>
+            <a:r>
+              <a:rPr lang="en-US" sz="1600" b="0" strike="noStrike" spc="-1" dirty="0" err="1">
+                <a:solidFill>
+                  <a:srgbClr val="000000"/>
+                </a:solidFill>
+                <a:latin typeface="Consolas"/>
+              </a:rPr>
+              <a:t>cpu</a:t>
+            </a:r>
+            <a:r>
+              <a:rPr lang="en-US" sz="1600" b="0" strike="noStrike" spc="-1" dirty="0">
+                <a:solidFill>
+                  <a:srgbClr val="000000"/>
+                </a:solidFill>
+                <a:latin typeface="Consolas"/>
+              </a:rPr>
+              <a:t>) * </a:t>
+            </a:r>
+            <a:r>
+              <a:rPr lang="en-US" sz="1600" b="0" strike="noStrike" spc="-1" dirty="0" err="1">
+                <a:solidFill>
+                  <a:srgbClr val="C9211E"/>
+                </a:solidFill>
+                <a:latin typeface="Consolas"/>
+              </a:rPr>
+              <a:t>fx_power</a:t>
+            </a:r>
+            <a:r>
+              <a:rPr lang="en-US" sz="1600" b="0" strike="noStrike" spc="-1" dirty="0">
+                <a:solidFill>
+                  <a:srgbClr val="C9211E"/>
+                </a:solidFill>
+                <a:latin typeface="Consolas"/>
+              </a:rPr>
+              <a:t>(</a:t>
+            </a:r>
+            <a:r>
+              <a:rPr lang="en-US" sz="1600" b="0" strike="noStrike" spc="-1" dirty="0" err="1">
+                <a:solidFill>
+                  <a:srgbClr val="C9211E"/>
+                </a:solidFill>
+                <a:latin typeface="Consolas"/>
+              </a:rPr>
+              <a:t>cpu</a:t>
+            </a:r>
+            <a:r>
+              <a:rPr lang="en-US" sz="1600" b="0" strike="noStrike" spc="-1" dirty="0">
+                <a:solidFill>
+                  <a:srgbClr val="C9211E"/>
+                </a:solidFill>
+                <a:latin typeface="Consolas"/>
+              </a:rPr>
+              <a:t>)</a:t>
+            </a:r>
+            <a:endParaRPr lang="en-US" sz="1600" b="0" strike="noStrike" spc="-1" dirty="0">
               <a:solidFill>
                 <a:srgbClr val="000000"/>
               </a:solidFill>
@@ -2715,7 +4205,7 @@
             </a:endParaRPr>
           </a:p>
           <a:p>
-            <a:pPr lvl="1" marL="864000" indent="-324000">
+            <a:pPr marL="864000" lvl="1" indent="-324000">
               <a:spcBef>
                 <a:spcPts val="1134"/>
               </a:spcBef>
@@ -2727,7 +4217,7 @@
               <a:buChar char=""/>
             </a:pPr>
             <a:r>
-              <a:rPr b="0" lang="en-US" sz="2400" spc="-1" strike="noStrike">
+              <a:rPr lang="en-US" sz="2400" b="0" strike="noStrike" spc="-1" dirty="0">
                 <a:solidFill>
                   <a:srgbClr val="000000"/>
                 </a:solidFill>
@@ -2736,7 +4226,7 @@
               <a:t>GPUs:</a:t>
             </a:r>
             <a:r>
-              <a:rPr b="0" lang="en-US" sz="2400" spc="-1" strike="noStrike">
+              <a:rPr lang="en-US" sz="2400" b="0" strike="noStrike" spc="-1" dirty="0">
                 <a:solidFill>
                   <a:srgbClr val="000000"/>
                 </a:solidFill>
@@ -2745,24 +4235,78 @@
               <a:t> </a:t>
             </a:r>
             <a:r>
-              <a:rPr b="0" lang="en-US" sz="1600" spc="-1" strike="noStrike">
+              <a:rPr lang="en-US" sz="1600" b="0" strike="noStrike" spc="-1" dirty="0">
                 <a:solidFill>
                   <a:srgbClr val="000000"/>
                 </a:solidFill>
                 <a:latin typeface="Consolas"/>
               </a:rPr>
-              <a:t>power(gpu) = weighted_frac(gpu) * </a:t>
-            </a:r>
-            <a:r>
-              <a:rPr b="0" lang="en-US" sz="1600" spc="-1" strike="noStrike">
-                <a:solidFill>
-                  <a:srgbClr val="c9211e"/>
+              <a:t>power(</a:t>
+            </a:r>
+            <a:r>
+              <a:rPr lang="en-US" sz="1600" b="0" strike="noStrike" spc="-1" dirty="0" err="1">
+                <a:solidFill>
+                  <a:srgbClr val="000000"/>
                 </a:solidFill>
                 <a:latin typeface="Consolas"/>
               </a:rPr>
+              <a:t>gpu</a:t>
+            </a:r>
+            <a:r>
+              <a:rPr lang="en-US" sz="1600" b="0" strike="noStrike" spc="-1" dirty="0">
+                <a:solidFill>
+                  <a:srgbClr val="000000"/>
+                </a:solidFill>
+                <a:latin typeface="Consolas"/>
+              </a:rPr>
+              <a:t>) = </a:t>
+            </a:r>
+            <a:r>
+              <a:rPr lang="en-US" sz="1600" b="0" strike="noStrike" spc="-1" dirty="0" err="1">
+                <a:solidFill>
+                  <a:srgbClr val="000000"/>
+                </a:solidFill>
+                <a:latin typeface="Consolas"/>
+              </a:rPr>
+              <a:t>weighted_frac</a:t>
+            </a:r>
+            <a:r>
+              <a:rPr lang="en-US" sz="1600" b="0" strike="noStrike" spc="-1" dirty="0">
+                <a:solidFill>
+                  <a:srgbClr val="000000"/>
+                </a:solidFill>
+                <a:latin typeface="Consolas"/>
+              </a:rPr>
+              <a:t>(</a:t>
+            </a:r>
+            <a:r>
+              <a:rPr lang="en-US" sz="1600" b="0" strike="noStrike" spc="-1" dirty="0" err="1">
+                <a:solidFill>
+                  <a:srgbClr val="000000"/>
+                </a:solidFill>
+                <a:latin typeface="Consolas"/>
+              </a:rPr>
+              <a:t>gpu</a:t>
+            </a:r>
+            <a:r>
+              <a:rPr lang="en-US" sz="1600" b="0" strike="noStrike" spc="-1" dirty="0">
+                <a:solidFill>
+                  <a:srgbClr val="000000"/>
+                </a:solidFill>
+                <a:latin typeface="Consolas"/>
+              </a:rPr>
+              <a:t>) * </a:t>
+            </a:r>
+            <a:r>
+              <a:rPr lang="en-US" sz="1600" b="0" strike="noStrike" spc="-1" dirty="0">
+                <a:solidFill>
+                  <a:srgbClr val="C9211E"/>
+                </a:solidFill>
+                <a:latin typeface="Consolas"/>
+              </a:rPr>
               <a:t>POWER_GPU</a:t>
             </a:r>
-            <a:endParaRPr b="0" lang="en-US" sz="1600" spc="-1" strike="noStrike">
+            <a:endParaRPr lang="en-US" sz="1600" b="0" strike="noStrike" spc="-1" dirty="0">
               <a:solidFill>
                 <a:srgbClr val="000000"/>
               </a:solidFill>
@@ -2770,7 +4314,7 @@
             </a:endParaRPr>
           </a:p>
           <a:p>
-            <a:pPr lvl="1" marL="864000" indent="-324000">
+            <a:pPr marL="864000" lvl="1" indent="-324000">
               <a:spcBef>
                 <a:spcPts val="1134"/>
               </a:spcBef>
@@ -2782,7 +4326,7 @@
               <a:buChar char=""/>
             </a:pPr>
             <a:r>
-              <a:rPr b="0" lang="en-US" sz="2400" spc="-1" strike="noStrike">
+              <a:rPr lang="en-US" sz="2400" b="0" strike="noStrike" spc="-1" dirty="0">
                 <a:solidFill>
                   <a:srgbClr val="000000"/>
                 </a:solidFill>
@@ -2790,15 +4334,9 @@
               </a:rPr>
               <a:t>Overhead: </a:t>
             </a:r>
-            <a:endParaRPr b="0" lang="en-US" sz="2400" spc="-1" strike="noStrike">
-              <a:solidFill>
-                <a:srgbClr val="000000"/>
-              </a:solidFill>
-              <a:latin typeface="Arial"/>
-            </a:endParaRPr>
-          </a:p>
-          <a:p>
-            <a:pPr lvl="2" marL="1296000" indent="-288000">
+          </a:p>
+          <a:p>
+            <a:pPr marL="1296000" lvl="2" indent="-288000">
               <a:spcBef>
                 <a:spcPts val="850"/>
               </a:spcBef>
@@ -2810,25 +4348,43 @@
               <a:buChar char=""/>
             </a:pPr>
             <a:r>
-              <a:rPr b="0" lang="en-US" sz="1600" spc="-1" strike="noStrike">
+              <a:rPr lang="en-US" sz="1600" b="0" strike="noStrike" spc="-1" dirty="0">
                 <a:solidFill>
                   <a:srgbClr val="000000"/>
                 </a:solidFill>
                 <a:latin typeface="Consolas"/>
               </a:rPr>
-              <a:t>(big_cpu_freq * </a:t>
-            </a:r>
-            <a:r>
-              <a:rPr b="0" lang="en-US" sz="1600" spc="-1" strike="noStrike">
-                <a:solidFill>
-                  <a:srgbClr val="c9211e"/>
+              <a:t>(</a:t>
+            </a:r>
+            <a:r>
+              <a:rPr lang="en-US" sz="1600" b="0" strike="noStrike" spc="-1" dirty="0" err="1">
+                <a:solidFill>
+                  <a:srgbClr val="000000"/>
                 </a:solidFill>
                 <a:latin typeface="Consolas"/>
               </a:rPr>
+              <a:t>big_cpu_freq</a:t>
+            </a:r>
+            <a:r>
+              <a:rPr lang="en-US" sz="1600" b="0" strike="noStrike" spc="-1" dirty="0">
+                <a:solidFill>
+                  <a:srgbClr val="000000"/>
+                </a:solidFill>
+                <a:latin typeface="Consolas"/>
+              </a:rPr>
+              <a:t> * </a:t>
+            </a:r>
+            <a:r>
+              <a:rPr lang="en-US" sz="1600" b="0" strike="noStrike" spc="-1" dirty="0" err="1">
+                <a:solidFill>
+                  <a:srgbClr val="C9211E"/>
+                </a:solidFill>
+                <a:latin typeface="Consolas"/>
+              </a:rPr>
               <a:t>big_cpu_overhead</a:t>
             </a:r>
             <a:r>
-              <a:rPr b="0" lang="en-US" sz="1600" spc="-1" strike="noStrike">
+              <a:rPr lang="en-US" sz="1600" b="0" strike="noStrike" spc="-1" dirty="0">
                 <a:solidFill>
                   <a:srgbClr val="000000"/>
                 </a:solidFill>
@@ -2836,7 +4392,7 @@
               </a:rPr>
               <a:t> + </a:t>
             </a:r>
-            <a:endParaRPr b="0" lang="en-US" sz="1600" spc="-1" strike="noStrike">
+            <a:endParaRPr lang="en-US" sz="1600" b="0" strike="noStrike" spc="-1" dirty="0">
               <a:solidFill>
                 <a:srgbClr val="000000"/>
               </a:solidFill>
@@ -2844,32 +4400,41 @@
             </a:endParaRPr>
           </a:p>
           <a:p>
-            <a:pPr lvl="2" marL="1296000" indent="0">
+            <a:pPr marL="1296000" lvl="2" indent="0">
               <a:spcBef>
                 <a:spcPts val="850"/>
               </a:spcBef>
               <a:buNone/>
             </a:pPr>
             <a:r>
-              <a:rPr b="0" lang="en-US" sz="1600" spc="-1" strike="noStrike">
+              <a:rPr lang="en-US" sz="1600" b="0" strike="noStrike" spc="-1" dirty="0" err="1">
                 <a:solidFill>
                   <a:srgbClr val="000000"/>
                 </a:solidFill>
                 <a:latin typeface="Consolas"/>
               </a:rPr>
-              <a:t>little_cpu_freq * </a:t>
-            </a:r>
-            <a:r>
-              <a:rPr b="0" lang="en-US" sz="1600" spc="-1" strike="noStrike">
-                <a:solidFill>
-                  <a:srgbClr val="c9211e"/>
+              <a:t>little_cpu_freq</a:t>
+            </a:r>
+            <a:r>
+              <a:rPr lang="en-US" sz="1600" b="0" strike="noStrike" spc="-1" dirty="0">
+                <a:solidFill>
+                  <a:srgbClr val="000000"/>
                 </a:solidFill>
                 <a:latin typeface="Consolas"/>
               </a:rPr>
+              <a:t> * </a:t>
+            </a:r>
+            <a:r>
+              <a:rPr lang="en-US" sz="1600" b="0" strike="noStrike" spc="-1" dirty="0" err="1">
+                <a:solidFill>
+                  <a:srgbClr val="C9211E"/>
+                </a:solidFill>
+                <a:latin typeface="Consolas"/>
+              </a:rPr>
               <a:t>little_cpu_overhead</a:t>
             </a:r>
             <a:r>
-              <a:rPr b="0" lang="en-US" sz="1600" spc="-1" strike="noStrike">
+              <a:rPr lang="en-US" sz="1600" b="0" strike="noStrike" spc="-1" dirty="0">
                 <a:solidFill>
                   <a:srgbClr val="000000"/>
                 </a:solidFill>
@@ -2878,24 +4443,24 @@
               <a:t>) * </a:t>
             </a:r>
             <a:r>
-              <a:rPr b="0" lang="en-US" sz="1600" spc="-1" strike="noStrike">
-                <a:solidFill>
-                  <a:srgbClr val="c9211e"/>
+              <a:rPr lang="en-US" sz="1600" b="0" strike="noStrike" spc="-1" dirty="0" err="1">
+                <a:solidFill>
+                  <a:srgbClr val="C9211E"/>
                 </a:solidFill>
                 <a:latin typeface="Consolas"/>
               </a:rPr>
               <a:t>scale_</a:t>
             </a:r>
             <a:r>
-              <a:rPr b="0" lang="en-US" sz="1600" spc="-1" strike="noStrike">
-                <a:solidFill>
-                  <a:srgbClr val="00a933"/>
+              <a:rPr lang="en-US" sz="1600" b="0" strike="noStrike" spc="-1" dirty="0" err="1">
+                <a:solidFill>
+                  <a:srgbClr val="00A933"/>
                 </a:solidFill>
                 <a:latin typeface="Consolas"/>
               </a:rPr>
               <a:t>factor</a:t>
             </a:r>
-            <a:endParaRPr b="0" lang="en-US" sz="1600" spc="-1" strike="noStrike">
+            <a:endParaRPr lang="en-US" sz="1600" b="0" strike="noStrike" spc="-1" dirty="0">
               <a:solidFill>
                 <a:srgbClr val="000000"/>
               </a:solidFill>
@@ -2909,7 +4474,7 @@
               </a:spcBef>
               <a:buNone/>
             </a:pPr>
-            <a:endParaRPr b="0" lang="en-US" sz="1600" spc="-1" strike="noStrike">
+            <a:endParaRPr lang="en-US" sz="1600" b="0" strike="noStrike" spc="-1" dirty="0">
               <a:solidFill>
                 <a:srgbClr val="000000"/>
               </a:solidFill>
@@ -2924,42 +4489,24 @@
               <a:buNone/>
             </a:pPr>
             <a:r>
-              <a:rPr b="0" lang="en-US" sz="2000" spc="-1" strike="noStrike">
-                <a:solidFill>
-                  <a:srgbClr val="c9211e"/>
-                </a:solidFill>
-                <a:latin typeface="Arial"/>
-              </a:rPr>
-              <a:t>*: found by experiments</a:t>
-            </a:r>
-            <a:r>
-              <a:rPr b="0" lang="en-US" sz="2000" spc="-1" strike="noStrike">
-                <a:solidFill>
-                  <a:srgbClr val="c9211e"/>
-                </a:solidFill>
-                <a:latin typeface="Arial"/>
-              </a:rPr>
-              <a:t>	</a:t>
-            </a:r>
-            <a:r>
-              <a:rPr b="0" lang="en-US" sz="2000" spc="-1" strike="noStrike">
-                <a:solidFill>
-                  <a:srgbClr val="00a933"/>
-                </a:solidFill>
-                <a:latin typeface="Arial"/>
-              </a:rPr>
-              <a:t>	</a:t>
-            </a:r>
-            <a:r>
-              <a:rPr b="0" lang="en-US" sz="2000" spc="-1" strike="noStrike">
-                <a:solidFill>
-                  <a:srgbClr val="00a933"/>
-                </a:solidFill>
-                <a:latin typeface="Arial"/>
-              </a:rPr>
-              <a:t>*: found by trial and error</a:t>
-            </a:r>
-            <a:endParaRPr b="0" lang="en-US" sz="2000" spc="-1" strike="noStrike">
+              <a:rPr lang="en-US" sz="2000" b="0" strike="noStrike" spc="-1" dirty="0">
+                <a:solidFill>
+                  <a:srgbClr val="C9211E"/>
+                </a:solidFill>
+                <a:latin typeface="Arial"/>
+              </a:rPr>
+              <a:t>*: found by experiments	</a:t>
+            </a:r>
+            <a:r>
+              <a:rPr lang="en-US" sz="2000" b="0" strike="noStrike" spc="-1" dirty="0">
+                <a:solidFill>
+                  <a:srgbClr val="00A933"/>
+                </a:solidFill>
+                <a:latin typeface="Arial"/>
+              </a:rPr>
+              <a:t>	*: found by trial and error</a:t>
+            </a:r>
+            <a:endParaRPr lang="en-US" sz="2000" b="0" strike="noStrike" spc="-1" dirty="0">
               <a:solidFill>
                 <a:srgbClr val="000000"/>
               </a:solidFill>
@@ -2970,68 +4517,63 @@
       </p:sp>
     </p:spTree>
   </p:cSld>
-  <mc:AlternateContent>
-    <mc:Choice Requires="p14">
-      <p:transition spd="slow" p14:dur="2000"/>
-    </mc:Choice>
-    <mc:Fallback>
-      <p:transition spd="slow"/>
-    </mc:Fallback>
-  </mc:AlternateContent>
+  <p:clrMapOvr>
+    <a:masterClrMapping/>
+  </p:clrMapOvr>
 </p:sld>
 </file>
 
 <file path=ppt/theme/theme1.xml><?xml version="1.0" encoding="utf-8"?>
-<a:theme xmlns:a="http://schemas.openxmlformats.org/drawingml/2006/main" xmlns:r="http://schemas.openxmlformats.org/officeDocument/2006/relationships" name="Office">
+<a:theme xmlns:a="http://schemas.openxmlformats.org/drawingml/2006/main" name="Office">
   <a:themeElements>
     <a:clrScheme name="LibreOffice">
       <a:dk1>
         <a:srgbClr val="000000"/>
       </a:dk1>
       <a:lt1>
-        <a:srgbClr val="ffffff"/>
+        <a:srgbClr val="FFFFFF"/>
       </a:lt1>
       <a:dk2>
         <a:srgbClr val="000000"/>
       </a:dk2>
       <a:lt2>
-        <a:srgbClr val="ffffff"/>
+        <a:srgbClr val="FFFFFF"/>
       </a:lt2>
       <a:accent1>
-        <a:srgbClr val="18a303"/>
+        <a:srgbClr val="18A303"/>
       </a:accent1>
       <a:accent2>
-        <a:srgbClr val="0369a3"/>
+        <a:srgbClr val="0369A3"/>
       </a:accent2>
       <a:accent3>
-        <a:srgbClr val="a33e03"/>
+        <a:srgbClr val="A33E03"/>
       </a:accent3>
       <a:accent4>
-        <a:srgbClr val="8e03a3"/>
+        <a:srgbClr val="8E03A3"/>
       </a:accent4>
       <a:accent5>
-        <a:srgbClr val="c99c00"/>
+        <a:srgbClr val="C99C00"/>
       </a:accent5>
       <a:accent6>
-        <a:srgbClr val="c9211e"/>
+        <a:srgbClr val="C9211E"/>
       </a:accent6>
       <a:hlink>
-        <a:srgbClr val="0000ee"/>
+        <a:srgbClr val="0000EE"/>
       </a:hlink>
       <a:folHlink>
-        <a:srgbClr val="551a8b"/>
+        <a:srgbClr val="551A8B"/>
       </a:folHlink>
     </a:clrScheme>
     <a:fontScheme name="Office">
       <a:majorFont>
-        <a:latin typeface="Arial" pitchFamily="0" charset="1"/>
-        <a:ea typeface="DejaVu Sans" pitchFamily="0" charset="1"/>
-        <a:cs typeface="DejaVu Sans" pitchFamily="0" charset="1"/>
+        <a:latin typeface="Arial"/>
+        <a:ea typeface="DejaVu Sans"/>
+        <a:cs typeface="DejaVu Sans"/>
       </a:majorFont>
       <a:minorFont>
-        <a:latin typeface="Arial" pitchFamily="0" charset="1"/>
-        <a:ea typeface="DejaVu Sans" pitchFamily="0" charset="1"/>
-        <a:cs typeface="DejaVu Sans" pitchFamily="0" charset="1"/>
+        <a:latin typeface="Arial"/>
+        <a:ea typeface="DejaVu Sans"/>
+        <a:cs typeface="DejaVu Sans"/>
       </a:minorFont>
     </a:fontScheme>
     <a:fmtScheme>
@@ -3084,5 +4626,7 @@
       </a:bgFillStyleLst>
     </a:fmtScheme>
   </a:themeElements>
+  <a:objectDefaults/>
+  <a:extraClrSchemeLst/>
 </a:theme>
 </file>
</xml_diff>